<commit_message>
Soluzioni L3: correzione di una cella
Co-Authored-By: Claude Opus 5.5 <noreply@anthropic.com>
Claude-Session: https://claude.ai/code/session_014CzWDFXvYNxqLeD99LSN3G
</commit_message>
<xml_diff>
--- a/L03_pulizia/slide_complete.pptx
+++ b/L03_pulizia/slide_complete.pptx
@@ -19,9 +19,10 @@
     <p:sldId id="267" r:id="rId13"/>
     <p:sldId id="268" r:id="rId14"/>
     <p:sldId id="269" r:id="rId15"/>
+    <p:sldId id="270" r:id="rId16"/>
   </p:sldIdLst>
   <p:notesMasterIdLst>
-    <p:notesMasterId r:id="rId16"/>
+    <p:notesMasterId r:id="rId17"/>
   </p:notesMasterIdLst>
   <p:sldSz cx="12192000" cy="6858000"/>
   <p:notesSz cx="6858000" cy="12192000"/>
@@ -120,38 +121,39 @@
   <p:extLst>
     <p:ext uri="{521415D9-36F7-43E2-AB2F-B90AF26B5E84}">
       <p14:sectionLst xmlns:p14="http://schemas.microsoft.com/office/powerpoint/2010/main">
-        <p14:section name="Apertura" id="{d6ccf1b1-a8a2-19b0-402f-16237024e1e6}">
+        <p14:section name="Apertura" id="{954befb0-530a-1f69-971e-7f3b7e97c9c2}">
           <p14:sldIdLst>
             <p14:sldId id="256"/>
             <p14:sldId id="257"/>
           </p14:sldIdLst>
         </p14:section>
-        <p14:section name="Spiegazione" id="{f6b7fb07-cf81-7b76-406f-5029b9150012}">
+        <p14:section name="Spiegazione" id="{8c7b922f-8abf-4641-a25b-55f9b1c6211a}">
           <p14:sldIdLst>
             <p14:sldId id="258"/>
             <p14:sldId id="259"/>
             <p14:sldId id="260"/>
             <p14:sldId id="261"/>
             <p14:sldId id="262"/>
-          </p14:sldIdLst>
-        </p14:section>
-        <p14:section name="Task" id="{43464b71-0c93-f789-08a5-62d9ff05e94f}">
-          <p14:sldIdLst>
             <p14:sldId id="263"/>
           </p14:sldIdLst>
         </p14:section>
-        <p14:section name="Debrief" id="{c76a9860-3a79-a112-9e17-7074aa45c6c7}">
+        <p14:section name="Task" id="{f43bad5d-10f8-91ab-a041-72297cd8e125}">
           <p14:sldIdLst>
             <p14:sldId id="264"/>
+          </p14:sldIdLst>
+        </p14:section>
+        <p14:section name="Debrief" id="{e8ec17cb-68ee-a864-1727-6699576f08ab}">
+          <p14:sldIdLst>
             <p14:sldId id="265"/>
             <p14:sldId id="266"/>
             <p14:sldId id="267"/>
             <p14:sldId id="268"/>
+            <p14:sldId id="269"/>
           </p14:sldIdLst>
         </p14:section>
-        <p14:section name="Chiusura" id="{b141caa9-e23f-7976-2e50-e0e15a82edf5}">
+        <p14:section name="Chiusura" id="{5abb5154-0f27-f1a1-4ec9-beaa627c6529}">
           <p14:sldIdLst>
-            <p14:sldId id="269"/>
+            <p14:sldId id="270"/>
           </p14:sldIdLst>
         </p14:section>
       </p14:sectionLst>
@@ -646,7 +648,7 @@
           <a:p>
             <a:r>
               <a:rPr lang="en-US" dirty="0"/>
-              <a:t>Chi ha ottenuto 1.621? Come se n'è accorto? Se qualcuno ha usato Gemini: l'ordine giusto l'ha azzeccato?</a:t>
+              <a:t/>
             </a:r>
             <a:endParaRPr lang="en-US" dirty="0"/>
           </a:p>
@@ -734,7 +736,7 @@
           <a:p>
             <a:r>
               <a:rPr lang="en-US" dirty="0"/>
-              <a:t>Valori in migliaia di euro. Chiedere che soglie hanno scelto: qualunque valore tra circa 65.000 e 300.000 dà lo stesso risultato. La scelta va giustificata, non indovinata.</a:t>
+              <a:t>Chi ha ottenuto 1.621? Come se n'è accorto? Se qualcuno ha usato Gemini: l'ordine giusto l'ha azzeccato?</a:t>
             </a:r>
             <a:endParaRPr lang="en-US" dirty="0"/>
           </a:p>
@@ -822,7 +824,7 @@
           <a:p>
             <a:r>
               <a:rPr lang="en-US" dirty="0"/>
-              <a:t>Valle D'Aosta con la D maiuscola sembra innocuo, ma nella L5 farà fallire l'unione con la tabella delle regioni.</a:t>
+              <a:t>Valori in migliaia di euro. Chiedere che soglie hanno scelto: qualunque valore tra circa 65.000 e 300.000 dà lo stesso risultato. La scelta va giustificata, non indovinata.</a:t>
             </a:r>
             <a:endParaRPr lang="en-US" dirty="0"/>
           </a:p>
@@ -910,7 +912,7 @@
           <a:p>
             <a:r>
               <a:rPr lang="en-US" dirty="0"/>
-              <a:t/>
+              <a:t>Valle D'Aosta con la D maiuscola sembra innocuo, ma nella L5 farà fallire l'unione con la tabella delle regioni.</a:t>
             </a:r>
             <a:endParaRPr lang="en-US" dirty="0"/>
           </a:p>
@@ -1040,6 +1042,94 @@
 </p:notes>
 </file>
 
+<file path=ppt/notesSlides/notesSlide15.xml><?xml version="1.0" encoding="utf-8"?>
+<p:notes xmlns:a="http://schemas.openxmlformats.org/drawingml/2006/main" xmlns:r="http://schemas.openxmlformats.org/officeDocument/2006/relationships" xmlns:p="http://schemas.openxmlformats.org/presentationml/2006/main">
+  <p:cSld>
+    <p:spTree>
+      <p:nvGrpSpPr>
+        <p:cNvPr id="1" name=""/>
+        <p:cNvGrpSpPr/>
+        <p:nvPr/>
+      </p:nvGrpSpPr>
+      <p:grpSpPr>
+        <a:xfrm>
+          <a:off x="0" y="0"/>
+          <a:ext cx="0" cy="0"/>
+          <a:chOff x="0" y="0"/>
+          <a:chExt cx="0" cy="0"/>
+        </a:xfrm>
+      </p:grpSpPr>
+      <p:sp>
+        <p:nvSpPr>
+          <p:cNvPr id="2" name="Slide Image Placeholder 1"/>
+          <p:cNvSpPr>
+            <a:spLocks noGrp="1" noRot="1" noChangeAspect="1"/>
+          </p:cNvSpPr>
+          <p:nvPr>
+            <p:ph type="sldImg"/>
+          </p:nvPr>
+        </p:nvSpPr>
+        <p:spPr/>
+      </p:sp>
+      <p:sp>
+        <p:nvSpPr>
+          <p:cNvPr id="3" name="Notes Placeholder 2"/>
+          <p:cNvSpPr>
+            <a:spLocks noGrp="1"/>
+          </p:cNvSpPr>
+          <p:nvPr>
+            <p:ph type="body" idx="1"/>
+          </p:nvPr>
+        </p:nvSpPr>
+        <p:spPr/>
+        <p:txBody>
+          <a:bodyPr/>
+          <a:lstStyle/>
+          <a:p>
+            <a:r>
+              <a:rPr lang="en-US" dirty="0"/>
+              <a:t/>
+            </a:r>
+            <a:endParaRPr lang="en-US" dirty="0"/>
+          </a:p>
+        </p:txBody>
+      </p:sp>
+      <p:sp>
+        <p:nvSpPr>
+          <p:cNvPr id="4" name="Slide Number Placeholder 3"/>
+          <p:cNvSpPr>
+            <a:spLocks noGrp="1"/>
+          </p:cNvSpPr>
+          <p:nvPr>
+            <p:ph type="sldNum" sz="quarter" idx="10"/>
+          </p:nvPr>
+        </p:nvSpPr>
+        <p:spPr/>
+        <p:txBody>
+          <a:bodyPr/>
+          <a:lstStyle/>
+          <a:p>
+            <a:fld id="{F7021451-1387-4CA6-816F-3879F97B5CBC}" type="slidenum">
+              <a:rPr lang="en-US"/>
+              <a:t>15</a:t>
+            </a:fld>
+            <a:endParaRPr lang="en-US"/>
+          </a:p>
+        </p:txBody>
+      </p:sp>
+    </p:spTree>
+    <p:extLst>
+      <p:ext uri="{BB962C8B-B14F-4D97-AF65-F5344CB8AC3E}">
+        <p14:creationId xmlns:p14="http://schemas.microsoft.com/office/powerpoint/2010/main" val="1024086991"/>
+      </p:ext>
+    </p:extLst>
+  </p:cSld>
+  <p:clrMapOvr>
+    <a:masterClrMapping/>
+  </p:clrMapOvr>
+</p:notes>
+</file>
+
 <file path=ppt/notesSlides/notesSlide2.xml><?xml version="1.0" encoding="utf-8"?>
 <p:notes xmlns:a="http://schemas.openxmlformats.org/drawingml/2006/main" xmlns:r="http://schemas.openxmlformats.org/officeDocument/2006/relationships" xmlns:p="http://schemas.openxmlformats.org/presentationml/2006/main">
   <p:cSld>
@@ -1614,7 +1704,7 @@
           <a:p>
             <a:r>
               <a:rPr lang="en-US" dirty="0"/>
-              <a:t>Girando tra i banchi: tenere d'occhio il passo 5. Chi trova più di 50 mancanti ha sbagliato l'ordine delle sostituzioni: non dirglielo, chiedergli se il numero torna.</a:t>
+              <a:t>L'esempio usa un dataset inventato (clienti e ordini) per non anticipare il task. Insistere sul controllo riga.sum() == 1 prima di modificare: se dà 0 la condizione è sbagliata, se dà più di 1 stai per cambiare più celle.</a:t>
             </a:r>
             <a:endParaRPr lang="en-US" dirty="0"/>
           </a:p>
@@ -1702,7 +1792,7 @@
           <a:p>
             <a:r>
               <a:rPr lang="en-US" dirty="0"/>
-              <a:t/>
+              <a:t>Girando tra i banchi: tenere d'occhio il passo 5. Chi trova più di 50 mancanti ha sbagliato l'ordine delle sostituzioni: non dirglielo, chiedergli se il numero torna.</a:t>
             </a:r>
             <a:endParaRPr lang="en-US" dirty="0"/>
           </a:p>
@@ -2599,450 +2689,69 @@
         </p:nvSpPr>
         <p:spPr>
           <a:xfrm>
-            <a:off x="548640" y="365760"/>
-            <a:ext cx="11064240" cy="822960"/>
-          </a:xfrm>
-          <a:prstGeom prst="rect">
-            <a:avLst/>
-          </a:prstGeom>
-          <a:noFill/>
-          <a:ln/>
-        </p:spPr>
-        <p:txBody>
-          <a:bodyPr wrap="square" lIns="0" tIns="0" rIns="0" bIns="0" rtlCol="0" anchor="ctr"/>
+            <a:off x="731520" y="2194560"/>
+            <a:ext cx="10698480" cy="1280160"/>
+          </a:xfrm>
+          <a:prstGeom prst="rect">
+            <a:avLst/>
+          </a:prstGeom>
+          <a:noFill/>
+          <a:ln/>
+        </p:spPr>
+        <p:txBody>
+          <a:bodyPr wrap="square" lIns="0" tIns="0" rIns="0" bIns="0" rtlCol="0" anchor="b"/>
           <a:lstStyle/>
           <a:p>
             <a:pPr algn="l" indent="0" marL="0">
               <a:buNone/>
             </a:pPr>
             <a:r>
-              <a:rPr lang="en-US" sz="3600" b="1" dirty="0">
-                <a:solidFill>
-                  <a:srgbClr val="0F4C5C"/>
-                </a:solidFill>
-              </a:rPr>
-              <a:t>L'ordine delle sostituzioni conta</a:t>
-            </a:r>
-            <a:endParaRPr lang="en-US" sz="3600" dirty="0"/>
-          </a:p>
-        </p:txBody>
-      </p:sp>
-      <p:sp>
-        <p:nvSpPr>
-          <p:cNvPr id="3" name="Shape 1"/>
+              <a:rPr lang="en-US" sz="5400" b="1" dirty="0">
+                <a:solidFill>
+                  <a:srgbClr val="FFFFFF"/>
+                </a:solidFill>
+              </a:rPr>
+              <a:t>Debrief</a:t>
+            </a:r>
+            <a:endParaRPr lang="en-US" sz="5400" dirty="0"/>
+          </a:p>
+        </p:txBody>
+      </p:sp>
+      <p:sp>
+        <p:nvSpPr>
+          <p:cNvPr id="3" name="Text 0"/>
           <p:cNvSpPr/>
-          <p:nvPr/>
-        </p:nvSpPr>
-        <p:spPr>
-          <a:xfrm>
-            <a:off x="548640" y="1737360"/>
-            <a:ext cx="5440680" cy="3291840"/>
-          </a:xfrm>
-          <a:prstGeom prst="roundRect">
-            <a:avLst>
-              <a:gd name="adj" fmla="val 3333"/>
-            </a:avLst>
-          </a:prstGeom>
-          <a:solidFill>
-            <a:srgbClr val="EEF3F4"/>
-          </a:solidFill>
-          <a:ln/>
-        </p:spPr>
-      </p:sp>
-      <p:sp>
-        <p:nvSpPr>
-          <p:cNvPr id="4" name="Text 2"/>
-          <p:cNvSpPr txBox="1"/>
-          <p:nvPr/>
-        </p:nvSpPr>
-        <p:spPr>
-          <a:xfrm>
-            <a:off x="914400" y="1965960"/>
-            <a:ext cx="4754880" cy="457200"/>
-          </a:xfrm>
-          <a:prstGeom prst="rect">
-            <a:avLst/>
-          </a:prstGeom>
-          <a:noFill/>
-          <a:ln/>
-        </p:spPr>
-        <p:txBody>
-          <a:bodyPr wrap="square" lIns="0" tIns="0" rIns="0" bIns="0" rtlCol="0" anchor="ctr"/>
-          <a:lstStyle/>
-          <a:p>
-            <a:pPr indent="0" marL="0">
-              <a:buNone/>
-            </a:pPr>
-            <a:r>
-              <a:rPr lang="en-US" sz="2400" b="1" dirty="0">
-                <a:solidFill>
-                  <a:srgbClr val="1F2A30"/>
-                </a:solidFill>
-              </a:rPr>
-              <a:t>Prima la virgola</a:t>
-            </a:r>
-            <a:endParaRPr lang="en-US" sz="2400" dirty="0"/>
-          </a:p>
-        </p:txBody>
-      </p:sp>
-      <p:sp>
-        <p:nvSpPr>
-          <p:cNvPr id="5" name="Text 3"/>
-          <p:cNvSpPr txBox="1"/>
-          <p:nvPr/>
-        </p:nvSpPr>
-        <p:spPr>
-          <a:xfrm>
-            <a:off x="914400" y="2468880"/>
-            <a:ext cx="4754880" cy="457200"/>
-          </a:xfrm>
-          <a:prstGeom prst="rect">
-            <a:avLst/>
-          </a:prstGeom>
-          <a:noFill/>
-          <a:ln/>
-        </p:spPr>
-        <p:txBody>
-          <a:bodyPr wrap="square" lIns="0" tIns="0" rIns="0" bIns="0" rtlCol="0" anchor="ctr"/>
-          <a:lstStyle/>
-          <a:p>
-            <a:pPr indent="0" marL="0">
-              <a:buNone/>
-            </a:pPr>
-            <a:r>
-              <a:rPr lang="en-US" sz="1500" dirty="0">
-                <a:solidFill>
-                  <a:srgbClr val="1F2A30"/>
-                </a:solidFill>
-                <a:latin typeface="Courier New" pitchFamily="34" charset="0"/>
-                <a:ea typeface="Courier New" pitchFamily="34" charset="-122"/>
-                <a:cs typeface="Courier New" pitchFamily="34" charset="-120"/>
-              </a:rPr>
-              <a:t>"1.032,9" → "1.032.9"</a:t>
-            </a:r>
-            <a:endParaRPr lang="en-US" sz="1500" dirty="0"/>
-          </a:p>
-        </p:txBody>
-      </p:sp>
-      <p:sp>
-        <p:nvSpPr>
-          <p:cNvPr id="6" name="Text 4"/>
-          <p:cNvSpPr txBox="1"/>
-          <p:nvPr/>
-        </p:nvSpPr>
-        <p:spPr>
-          <a:xfrm>
-            <a:off x="914400" y="3108960"/>
-            <a:ext cx="4754880" cy="1097280"/>
-          </a:xfrm>
-          <a:prstGeom prst="rect">
-            <a:avLst/>
-          </a:prstGeom>
-          <a:noFill/>
-          <a:ln/>
-        </p:spPr>
-        <p:txBody>
-          <a:bodyPr wrap="square" lIns="0" tIns="0" rIns="0" bIns="0" rtlCol="0" anchor="ctr"/>
-          <a:lstStyle/>
-          <a:p>
-            <a:pPr indent="0" marL="0">
-              <a:buNone/>
-            </a:pPr>
-            <a:r>
-              <a:rPr lang="en-US" sz="6400" b="1" dirty="0">
-                <a:solidFill>
-                  <a:srgbClr val="9E2A2B"/>
-                </a:solidFill>
-              </a:rPr>
-              <a:t>1.621</a:t>
-            </a:r>
-            <a:endParaRPr lang="en-US" sz="6400" dirty="0"/>
-          </a:p>
-        </p:txBody>
-      </p:sp>
-      <p:sp>
-        <p:nvSpPr>
-          <p:cNvPr id="7" name="Text 5"/>
-          <p:cNvSpPr txBox="1"/>
-          <p:nvPr/>
-        </p:nvSpPr>
-        <p:spPr>
-          <a:xfrm>
-            <a:off x="914400" y="4251960"/>
-            <a:ext cx="4754880" cy="457200"/>
-          </a:xfrm>
-          <a:prstGeom prst="rect">
-            <a:avLst/>
-          </a:prstGeom>
-          <a:noFill/>
-          <a:ln/>
-        </p:spPr>
-        <p:txBody>
-          <a:bodyPr wrap="square" lIns="0" tIns="0" rIns="0" bIns="0" rtlCol="0" anchor="ctr"/>
-          <a:lstStyle/>
-          <a:p>
-            <a:pPr indent="0" marL="0">
-              <a:buNone/>
-            </a:pPr>
-            <a:r>
-              <a:rPr lang="en-US" sz="2000" dirty="0">
-                <a:solidFill>
-                  <a:srgbClr val="1F2A30"/>
-                </a:solidFill>
-              </a:rPr>
-              <a:t>valori mancanti</a:t>
-            </a:r>
-            <a:endParaRPr lang="en-US" sz="2000" dirty="0"/>
-          </a:p>
-        </p:txBody>
-      </p:sp>
-      <p:sp>
-        <p:nvSpPr>
-          <p:cNvPr id="8" name="Shape 6"/>
-          <p:cNvSpPr/>
-          <p:nvPr/>
-        </p:nvSpPr>
-        <p:spPr>
-          <a:xfrm>
-            <a:off x="6172200" y="1737360"/>
-            <a:ext cx="5440680" cy="3291840"/>
-          </a:xfrm>
-          <a:prstGeom prst="roundRect">
-            <a:avLst>
-              <a:gd name="adj" fmla="val 3333"/>
-            </a:avLst>
-          </a:prstGeom>
-          <a:solidFill>
-            <a:srgbClr val="0F4C5C"/>
-          </a:solidFill>
-          <a:ln/>
-        </p:spPr>
-      </p:sp>
-      <p:sp>
-        <p:nvSpPr>
-          <p:cNvPr id="9" name="Text 7"/>
-          <p:cNvSpPr txBox="1"/>
-          <p:nvPr/>
-        </p:nvSpPr>
-        <p:spPr>
-          <a:xfrm>
-            <a:off x="6537960" y="1965960"/>
-            <a:ext cx="4754880" cy="457200"/>
-          </a:xfrm>
-          <a:prstGeom prst="rect">
-            <a:avLst/>
-          </a:prstGeom>
-          <a:noFill/>
-          <a:ln/>
-        </p:spPr>
-        <p:txBody>
-          <a:bodyPr wrap="square" lIns="0" tIns="0" rIns="0" bIns="0" rtlCol="0" anchor="ctr"/>
-          <a:lstStyle/>
-          <a:p>
-            <a:pPr indent="0" marL="0">
-              <a:buNone/>
-            </a:pPr>
-            <a:r>
-              <a:rPr lang="en-US" sz="2400" b="1" dirty="0">
-                <a:solidFill>
-                  <a:srgbClr val="FFFFFF"/>
-                </a:solidFill>
-              </a:rPr>
-              <a:t>Prima il punto</a:t>
-            </a:r>
-            <a:endParaRPr lang="en-US" sz="2400" dirty="0"/>
-          </a:p>
-        </p:txBody>
-      </p:sp>
-      <p:sp>
-        <p:nvSpPr>
-          <p:cNvPr id="10" name="Text 8"/>
-          <p:cNvSpPr txBox="1"/>
-          <p:nvPr/>
-        </p:nvSpPr>
-        <p:spPr>
-          <a:xfrm>
-            <a:off x="6537960" y="2468880"/>
-            <a:ext cx="4754880" cy="457200"/>
-          </a:xfrm>
-          <a:prstGeom prst="rect">
-            <a:avLst/>
-          </a:prstGeom>
-          <a:noFill/>
-          <a:ln/>
-        </p:spPr>
-        <p:txBody>
-          <a:bodyPr wrap="square" lIns="0" tIns="0" rIns="0" bIns="0" rtlCol="0" anchor="ctr"/>
-          <a:lstStyle/>
-          <a:p>
-            <a:pPr indent="0" marL="0">
-              <a:buNone/>
-            </a:pPr>
-            <a:r>
-              <a:rPr lang="en-US" sz="1500" dirty="0">
-                <a:solidFill>
-                  <a:srgbClr val="FFFFFF"/>
-                </a:solidFill>
-                <a:latin typeface="Courier New" pitchFamily="34" charset="0"/>
-                <a:ea typeface="Courier New" pitchFamily="34" charset="-122"/>
-                <a:cs typeface="Courier New" pitchFamily="34" charset="-120"/>
-              </a:rPr>
-              <a:t>"1.032,9" → "1032,9" → "1032.9"</a:t>
-            </a:r>
-            <a:endParaRPr lang="en-US" sz="1500" dirty="0"/>
-          </a:p>
-        </p:txBody>
-      </p:sp>
-      <p:sp>
-        <p:nvSpPr>
-          <p:cNvPr id="11" name="Text 9"/>
-          <p:cNvSpPr txBox="1"/>
-          <p:nvPr/>
-        </p:nvSpPr>
-        <p:spPr>
-          <a:xfrm>
-            <a:off x="6537960" y="3108960"/>
-            <a:ext cx="4754880" cy="1097280"/>
-          </a:xfrm>
-          <a:prstGeom prst="rect">
-            <a:avLst/>
-          </a:prstGeom>
-          <a:noFill/>
-          <a:ln/>
-        </p:spPr>
-        <p:txBody>
-          <a:bodyPr wrap="square" lIns="0" tIns="0" rIns="0" bIns="0" rtlCol="0" anchor="ctr"/>
-          <a:lstStyle/>
-          <a:p>
-            <a:pPr indent="0" marL="0">
-              <a:buNone/>
-            </a:pPr>
-            <a:r>
-              <a:rPr lang="en-US" sz="6400" b="1" dirty="0">
-                <a:solidFill>
-                  <a:srgbClr val="FFFFFF"/>
-                </a:solidFill>
-              </a:rPr>
-              <a:t>50</a:t>
-            </a:r>
-            <a:endParaRPr lang="en-US" sz="6400" dirty="0"/>
-          </a:p>
-        </p:txBody>
-      </p:sp>
-      <p:sp>
-        <p:nvSpPr>
-          <p:cNvPr id="12" name="Text 10"/>
-          <p:cNvSpPr txBox="1"/>
-          <p:nvPr/>
-        </p:nvSpPr>
-        <p:spPr>
-          <a:xfrm>
-            <a:off x="6537960" y="4251960"/>
-            <a:ext cx="4754880" cy="457200"/>
-          </a:xfrm>
-          <a:prstGeom prst="rect">
-            <a:avLst/>
-          </a:prstGeom>
-          <a:noFill/>
-          <a:ln/>
-        </p:spPr>
-        <p:txBody>
-          <a:bodyPr wrap="square" lIns="0" tIns="0" rIns="0" bIns="0" rtlCol="0" anchor="ctr"/>
-          <a:lstStyle/>
-          <a:p>
-            <a:pPr indent="0" marL="0">
-              <a:buNone/>
-            </a:pPr>
-            <a:r>
-              <a:rPr lang="en-US" sz="2000" dirty="0">
-                <a:solidFill>
-                  <a:srgbClr val="FFFFFF"/>
-                </a:solidFill>
-              </a:rPr>
-              <a:t>valori mancanti</a:t>
-            </a:r>
-            <a:endParaRPr lang="en-US" sz="2000" dirty="0"/>
-          </a:p>
-        </p:txBody>
-      </p:sp>
-      <p:sp>
-        <p:nvSpPr>
-          <p:cNvPr id="13" name="Text 11"/>
-          <p:cNvSpPr txBox="1"/>
-          <p:nvPr/>
-        </p:nvSpPr>
-        <p:spPr>
-          <a:xfrm>
-            <a:off x="548640" y="5349240"/>
-            <a:ext cx="11064240" cy="457200"/>
-          </a:xfrm>
-          <a:prstGeom prst="rect">
-            <a:avLst/>
-          </a:prstGeom>
-          <a:noFill/>
-          <a:ln/>
-        </p:spPr>
-        <p:txBody>
-          <a:bodyPr wrap="square" lIns="0" tIns="0" rIns="0" bIns="0" rtlCol="0" anchor="ctr"/>
-          <a:lstStyle/>
-          <a:p>
-            <a:pPr indent="0" marL="0">
-              <a:buNone/>
-            </a:pPr>
-            <a:r>
-              <a:rPr lang="en-US" sz="1800" i="1" dirty="0">
-                <a:solidFill>
-                  <a:srgbClr val="0F4C5C"/>
-                </a:solidFill>
-              </a:rPr>
-              <a:t>Stesso codice, stesse funzioni, nessun errore. Solo il conteggio dei mancanti ti salva.</a:t>
-            </a:r>
-            <a:endParaRPr lang="en-US" sz="1800" dirty="0"/>
-          </a:p>
-        </p:txBody>
-      </p:sp>
-      <p:sp>
-        <p:nvSpPr>
-          <p:cNvPr id="25" name="Slide Number Placeholder 0"/>
-          <p:cNvSpPr>
-            <a:spLocks noGrp="1"/>
-          </p:cNvSpPr>
           <p:nvPr>
-            <p:ph type="sldNum" sz="quarter" idx="4294967295"/>
+            <p:ph idx="101" type="body" hasCustomPrompt="1"/>
           </p:nvPr>
         </p:nvSpPr>
         <p:spPr>
           <a:xfrm>
-            <a:off x="11155680" y="6400800"/>
-            <a:ext cx="457200" cy="274320"/>
-          </a:xfrm>
-          <a:prstGeom prst="rect">
-            <a:avLst/>
-          </a:prstGeom>
-          <a:extLst>
-            <a:ext uri="{C572A759-6A51-4108-AA02-DFA0A04FC94B}">
-              <ma14:wrappingTextBoxFlag xmlns:ma14="http://schemas.microsoft.com/office/mac/drawingml/2011/main" val="0"/>
-            </a:ext>
-          </a:extLst>
-        </p:spPr>
-        <p:txBody>
-          <a:bodyPr/>
-          <a:lstStyle>
-            <a:lvl1pPr>
-              <a:defRPr sz="1000">
-                <a:solidFill>
-                  <a:srgbClr val="5C6F7B"/>
-                </a:solidFill>
-              </a:defRPr>
-            </a:lvl1pPr>
-          </a:lstStyle>
-          <a:p>
-            <a:pPr algn="r"/>
-            <a:fld id="{F7021451-1387-4CA6-816F-3879F97B5CBC}" type="slidenum">
-              <a:rPr b="0" lang="en-US"/>
-              <a:t>10</a:t>
-            </a:fld>
-            <a:endParaRPr lang="en-US"/>
+            <a:off x="731520" y="3657600"/>
+            <a:ext cx="10698480" cy="1463040"/>
+          </a:xfrm>
+          <a:prstGeom prst="rect">
+            <a:avLst/>
+          </a:prstGeom>
+          <a:noFill/>
+          <a:ln/>
+        </p:spPr>
+        <p:txBody>
+          <a:bodyPr wrap="square" lIns="0" tIns="0" rIns="0" bIns="0" rtlCol="0" anchor="t"/>
+          <a:lstStyle/>
+          <a:p>
+            <a:pPr indent="0" marL="0">
+              <a:buNone/>
+            </a:pPr>
+            <a:r>
+              <a:rPr lang="en-US" sz="2200" dirty="0">
+                <a:solidFill>
+                  <a:srgbClr val="B8C4CB"/>
+                </a:solidFill>
+              </a:rPr>
+              <a:t>Le trappole silenziose</a:t>
+            </a:r>
+            <a:endParaRPr lang="en-US" sz="2200" dirty="0"/>
           </a:p>
         </p:txBody>
       </p:sp>
@@ -3103,7 +2812,7 @@
                   <a:srgbClr val="0F4C5C"/>
                 </a:solidFill>
               </a:rPr>
-              <a:t>Un fatturato di 24 milioni?</a:t>
+              <a:t>L'ordine delle sostituzioni conta</a:t>
             </a:r>
             <a:endParaRPr lang="en-US" sz="3600" dirty="0"/>
           </a:p>
@@ -3118,11 +2827,11 @@
         <p:spPr>
           <a:xfrm>
             <a:off x="548640" y="1737360"/>
-            <a:ext cx="3657600" cy="2377440"/>
+            <a:ext cx="5440680" cy="3291840"/>
           </a:xfrm>
           <a:prstGeom prst="roundRect">
             <a:avLst>
-              <a:gd name="adj" fmla="val 4615"/>
+              <a:gd name="adj" fmla="val 3333"/>
             </a:avLst>
           </a:prstGeom>
           <a:solidFill>
@@ -3139,8 +2848,8 @@
         </p:nvSpPr>
         <p:spPr>
           <a:xfrm>
-            <a:off x="868680" y="2011680"/>
-            <a:ext cx="3017520" cy="1005840"/>
+            <a:off x="914400" y="1965960"/>
+            <a:ext cx="4754880" cy="457200"/>
           </a:xfrm>
           <a:prstGeom prst="rect">
             <a:avLst/>
@@ -3156,14 +2865,14 @@
               <a:buNone/>
             </a:pPr>
             <a:r>
-              <a:rPr lang="en-US" sz="5400" b="1" dirty="0">
-                <a:solidFill>
-                  <a:srgbClr val="0F4C5C"/>
-                </a:solidFill>
-              </a:rPr>
-              <a:t>1.407</a:t>
-            </a:r>
-            <a:endParaRPr lang="en-US" sz="5400" dirty="0"/>
+              <a:rPr lang="en-US" sz="2400" b="1" dirty="0">
+                <a:solidFill>
+                  <a:srgbClr val="1F2A30"/>
+                </a:solidFill>
+              </a:rPr>
+              <a:t>Prima la virgola</a:t>
+            </a:r>
+            <a:endParaRPr lang="en-US" sz="2400" dirty="0"/>
           </a:p>
         </p:txBody>
       </p:sp>
@@ -3175,8 +2884,8 @@
         </p:nvSpPr>
         <p:spPr>
           <a:xfrm>
-            <a:off x="868680" y="3154680"/>
-            <a:ext cx="3017520" cy="457200"/>
+            <a:off x="914400" y="2468880"/>
+            <a:ext cx="4754880" cy="457200"/>
           </a:xfrm>
           <a:prstGeom prst="rect">
             <a:avLst/>
@@ -3192,31 +2901,106 @@
               <a:buNone/>
             </a:pPr>
             <a:r>
-              <a:rPr lang="en-US" sz="1800" dirty="0">
-                <a:solidFill>
-                  <a:srgbClr val="0F4C5C"/>
-                </a:solidFill>
-              </a:rPr>
-              <a:t>fatturato mediano</a:t>
-            </a:r>
-            <a:endParaRPr lang="en-US" sz="1800" dirty="0"/>
-          </a:p>
-        </p:txBody>
-      </p:sp>
-      <p:sp>
-        <p:nvSpPr>
-          <p:cNvPr id="6" name="Shape 4"/>
+              <a:rPr lang="en-US" sz="1500" dirty="0">
+                <a:solidFill>
+                  <a:srgbClr val="1F2A30"/>
+                </a:solidFill>
+                <a:latin typeface="Courier New" pitchFamily="34" charset="0"/>
+                <a:ea typeface="Courier New" pitchFamily="34" charset="-122"/>
+                <a:cs typeface="Courier New" pitchFamily="34" charset="-120"/>
+              </a:rPr>
+              <a:t>"1.032,9" → "1.032.9"</a:t>
+            </a:r>
+            <a:endParaRPr lang="en-US" sz="1500" dirty="0"/>
+          </a:p>
+        </p:txBody>
+      </p:sp>
+      <p:sp>
+        <p:nvSpPr>
+          <p:cNvPr id="6" name="Text 4"/>
+          <p:cNvSpPr txBox="1"/>
+          <p:nvPr/>
+        </p:nvSpPr>
+        <p:spPr>
+          <a:xfrm>
+            <a:off x="914400" y="3108960"/>
+            <a:ext cx="4754880" cy="1097280"/>
+          </a:xfrm>
+          <a:prstGeom prst="rect">
+            <a:avLst/>
+          </a:prstGeom>
+          <a:noFill/>
+          <a:ln/>
+        </p:spPr>
+        <p:txBody>
+          <a:bodyPr wrap="square" lIns="0" tIns="0" rIns="0" bIns="0" rtlCol="0" anchor="ctr"/>
+          <a:lstStyle/>
+          <a:p>
+            <a:pPr indent="0" marL="0">
+              <a:buNone/>
+            </a:pPr>
+            <a:r>
+              <a:rPr lang="en-US" sz="6400" b="1" dirty="0">
+                <a:solidFill>
+                  <a:srgbClr val="9E2A2B"/>
+                </a:solidFill>
+              </a:rPr>
+              <a:t>1.621</a:t>
+            </a:r>
+            <a:endParaRPr lang="en-US" sz="6400" dirty="0"/>
+          </a:p>
+        </p:txBody>
+      </p:sp>
+      <p:sp>
+        <p:nvSpPr>
+          <p:cNvPr id="7" name="Text 5"/>
+          <p:cNvSpPr txBox="1"/>
+          <p:nvPr/>
+        </p:nvSpPr>
+        <p:spPr>
+          <a:xfrm>
+            <a:off x="914400" y="4251960"/>
+            <a:ext cx="4754880" cy="457200"/>
+          </a:xfrm>
+          <a:prstGeom prst="rect">
+            <a:avLst/>
+          </a:prstGeom>
+          <a:noFill/>
+          <a:ln/>
+        </p:spPr>
+        <p:txBody>
+          <a:bodyPr wrap="square" lIns="0" tIns="0" rIns="0" bIns="0" rtlCol="0" anchor="ctr"/>
+          <a:lstStyle/>
+          <a:p>
+            <a:pPr indent="0" marL="0">
+              <a:buNone/>
+            </a:pPr>
+            <a:r>
+              <a:rPr lang="en-US" sz="2000" dirty="0">
+                <a:solidFill>
+                  <a:srgbClr val="1F2A30"/>
+                </a:solidFill>
+              </a:rPr>
+              <a:t>valori mancanti</a:t>
+            </a:r>
+            <a:endParaRPr lang="en-US" sz="2000" dirty="0"/>
+          </a:p>
+        </p:txBody>
+      </p:sp>
+      <p:sp>
+        <p:nvSpPr>
+          <p:cNvPr id="8" name="Shape 6"/>
           <p:cNvSpPr/>
           <p:nvPr/>
         </p:nvSpPr>
         <p:spPr>
           <a:xfrm>
-            <a:off x="4480560" y="1737360"/>
-            <a:ext cx="3657600" cy="2377440"/>
+            <a:off x="6172200" y="1737360"/>
+            <a:ext cx="5440680" cy="3291840"/>
           </a:xfrm>
           <a:prstGeom prst="roundRect">
             <a:avLst>
-              <a:gd name="adj" fmla="val 4615"/>
+              <a:gd name="adj" fmla="val 3333"/>
             </a:avLst>
           </a:prstGeom>
           <a:solidFill>
@@ -3227,146 +3011,37 @@
       </p:sp>
       <p:sp>
         <p:nvSpPr>
-          <p:cNvPr id="7" name="Text 5"/>
-          <p:cNvSpPr txBox="1"/>
-          <p:nvPr/>
-        </p:nvSpPr>
-        <p:spPr>
-          <a:xfrm>
-            <a:off x="4800600" y="2011680"/>
-            <a:ext cx="3017520" cy="1005840"/>
-          </a:xfrm>
-          <a:prstGeom prst="rect">
-            <a:avLst/>
-          </a:prstGeom>
-          <a:noFill/>
-          <a:ln/>
-        </p:spPr>
-        <p:txBody>
-          <a:bodyPr wrap="square" lIns="0" tIns="0" rIns="0" bIns="0" rtlCol="0" anchor="ctr"/>
-          <a:lstStyle/>
-          <a:p>
-            <a:pPr indent="0" marL="0">
-              <a:buNone/>
-            </a:pPr>
-            <a:r>
-              <a:rPr lang="en-US" sz="4000" b="1" dirty="0">
-                <a:solidFill>
-                  <a:srgbClr val="FFFFFF"/>
-                </a:solidFill>
-              </a:rPr>
-              <a:t>24.586.100</a:t>
-            </a:r>
-            <a:endParaRPr lang="en-US" sz="4000" dirty="0"/>
-          </a:p>
-        </p:txBody>
-      </p:sp>
-      <p:sp>
-        <p:nvSpPr>
-          <p:cNvPr id="8" name="Text 6"/>
-          <p:cNvSpPr txBox="1"/>
-          <p:nvPr/>
-        </p:nvSpPr>
-        <p:spPr>
-          <a:xfrm>
-            <a:off x="4800600" y="3154680"/>
-            <a:ext cx="3017520" cy="457200"/>
-          </a:xfrm>
-          <a:prstGeom prst="rect">
-            <a:avLst/>
-          </a:prstGeom>
-          <a:noFill/>
-          <a:ln/>
-        </p:spPr>
-        <p:txBody>
-          <a:bodyPr wrap="square" lIns="0" tIns="0" rIns="0" bIns="0" rtlCol="0" anchor="ctr"/>
-          <a:lstStyle/>
-          <a:p>
-            <a:pPr indent="0" marL="0">
-              <a:buNone/>
-            </a:pPr>
-            <a:r>
-              <a:rPr lang="en-US" sz="1800" dirty="0">
-                <a:solidFill>
-                  <a:srgbClr val="FFFFFF"/>
-                </a:solidFill>
-              </a:rPr>
-              <a:t>fatturato massimo</a:t>
-            </a:r>
-            <a:endParaRPr lang="en-US" sz="1800" dirty="0"/>
-          </a:p>
-        </p:txBody>
-      </p:sp>
-      <p:sp>
-        <p:nvSpPr>
           <p:cNvPr id="9" name="Text 7"/>
           <p:cNvSpPr txBox="1"/>
           <p:nvPr/>
         </p:nvSpPr>
         <p:spPr>
           <a:xfrm>
-            <a:off x="8503920" y="1828800"/>
-            <a:ext cx="3108960" cy="4114800"/>
-          </a:xfrm>
-          <a:prstGeom prst="rect">
-            <a:avLst/>
-          </a:prstGeom>
-          <a:noFill/>
-          <a:ln/>
-        </p:spPr>
-        <p:txBody>
-          <a:bodyPr wrap="square" lIns="0" tIns="0" rIns="0" bIns="0" rtlCol="0" anchor="t"/>
-          <a:lstStyle/>
-          <a:p>
-            <a:pPr indent="0" marL="0">
-              <a:spcAft>
-                <a:spcPts val="1000"/>
-              </a:spcAft>
-              <a:buNone/>
-            </a:pPr>
-            <a:r>
-              <a:rPr lang="en-US" sz="1700" dirty="0">
-                <a:solidFill>
-                  <a:srgbClr val="1F2A30"/>
-                </a:solidFill>
-              </a:rPr>
-              <a:t>Cinque valori enormi, poi un salto netto.</a:t>
-            </a:r>
-            <a:endParaRPr lang="en-US" sz="1700" dirty="0"/>
-          </a:p>
-          <a:p>
-            <a:pPr indent="0" marL="0">
-              <a:spcAft>
-                <a:spcPts val="1000"/>
-              </a:spcAft>
-              <a:buNone/>
-            </a:pPr>
-            <a:r>
-              <a:rPr lang="en-US" sz="1700" dirty="0">
-                <a:solidFill>
-                  <a:srgbClr val="1F2A30"/>
-                </a:solidFill>
-              </a:rPr>
-              <a:t>Negli altri anni la stessa impresa fattura circa mille volte meno: inseriti in euro, non in migliaia.</a:t>
-            </a:r>
-            <a:endParaRPr lang="en-US" sz="1700" dirty="0"/>
-          </a:p>
-          <a:p>
-            <a:pPr indent="0" marL="0">
-              <a:spcAft>
-                <a:spcPts val="1000"/>
-              </a:spcAft>
-              <a:buNone/>
-            </a:pPr>
-            <a:r>
-              <a:rPr lang="en-US" sz="1700" b="1" dirty="0">
-                <a:solidFill>
-                  <a:srgbClr val="0F4C5C"/>
-                </a:solidFill>
-              </a:rPr>
-              <a:t>Decisione: soglia 200.000, divisi per 1.000.</a:t>
-            </a:r>
-            <a:endParaRPr lang="en-US" sz="1700" dirty="0"/>
+            <a:off x="6537960" y="1965960"/>
+            <a:ext cx="4754880" cy="457200"/>
+          </a:xfrm>
+          <a:prstGeom prst="rect">
+            <a:avLst/>
+          </a:prstGeom>
+          <a:noFill/>
+          <a:ln/>
+        </p:spPr>
+        <p:txBody>
+          <a:bodyPr wrap="square" lIns="0" tIns="0" rIns="0" bIns="0" rtlCol="0" anchor="ctr"/>
+          <a:lstStyle/>
+          <a:p>
+            <a:pPr indent="0" marL="0">
+              <a:buNone/>
+            </a:pPr>
+            <a:r>
+              <a:rPr lang="en-US" sz="2400" b="1" dirty="0">
+                <a:solidFill>
+                  <a:srgbClr val="FFFFFF"/>
+                </a:solidFill>
+              </a:rPr>
+              <a:t>Prima il punto</a:t>
+            </a:r>
+            <a:endParaRPr lang="en-US" sz="2400" dirty="0"/>
           </a:p>
         </p:txBody>
       </p:sp>
@@ -3378,7 +3053,118 @@
         </p:nvSpPr>
         <p:spPr>
           <a:xfrm>
-            <a:off x="548640" y="4572000"/>
+            <a:off x="6537960" y="2468880"/>
+            <a:ext cx="4754880" cy="457200"/>
+          </a:xfrm>
+          <a:prstGeom prst="rect">
+            <a:avLst/>
+          </a:prstGeom>
+          <a:noFill/>
+          <a:ln/>
+        </p:spPr>
+        <p:txBody>
+          <a:bodyPr wrap="square" lIns="0" tIns="0" rIns="0" bIns="0" rtlCol="0" anchor="ctr"/>
+          <a:lstStyle/>
+          <a:p>
+            <a:pPr indent="0" marL="0">
+              <a:buNone/>
+            </a:pPr>
+            <a:r>
+              <a:rPr lang="en-US" sz="1500" dirty="0">
+                <a:solidFill>
+                  <a:srgbClr val="FFFFFF"/>
+                </a:solidFill>
+                <a:latin typeface="Courier New" pitchFamily="34" charset="0"/>
+                <a:ea typeface="Courier New" pitchFamily="34" charset="-122"/>
+                <a:cs typeface="Courier New" pitchFamily="34" charset="-120"/>
+              </a:rPr>
+              <a:t>"1.032,9" → "1032,9" → "1032.9"</a:t>
+            </a:r>
+            <a:endParaRPr lang="en-US" sz="1500" dirty="0"/>
+          </a:p>
+        </p:txBody>
+      </p:sp>
+      <p:sp>
+        <p:nvSpPr>
+          <p:cNvPr id="11" name="Text 9"/>
+          <p:cNvSpPr txBox="1"/>
+          <p:nvPr/>
+        </p:nvSpPr>
+        <p:spPr>
+          <a:xfrm>
+            <a:off x="6537960" y="3108960"/>
+            <a:ext cx="4754880" cy="1097280"/>
+          </a:xfrm>
+          <a:prstGeom prst="rect">
+            <a:avLst/>
+          </a:prstGeom>
+          <a:noFill/>
+          <a:ln/>
+        </p:spPr>
+        <p:txBody>
+          <a:bodyPr wrap="square" lIns="0" tIns="0" rIns="0" bIns="0" rtlCol="0" anchor="ctr"/>
+          <a:lstStyle/>
+          <a:p>
+            <a:pPr indent="0" marL="0">
+              <a:buNone/>
+            </a:pPr>
+            <a:r>
+              <a:rPr lang="en-US" sz="6400" b="1" dirty="0">
+                <a:solidFill>
+                  <a:srgbClr val="FFFFFF"/>
+                </a:solidFill>
+              </a:rPr>
+              <a:t>50</a:t>
+            </a:r>
+            <a:endParaRPr lang="en-US" sz="6400" dirty="0"/>
+          </a:p>
+        </p:txBody>
+      </p:sp>
+      <p:sp>
+        <p:nvSpPr>
+          <p:cNvPr id="12" name="Text 10"/>
+          <p:cNvSpPr txBox="1"/>
+          <p:nvPr/>
+        </p:nvSpPr>
+        <p:spPr>
+          <a:xfrm>
+            <a:off x="6537960" y="4251960"/>
+            <a:ext cx="4754880" cy="457200"/>
+          </a:xfrm>
+          <a:prstGeom prst="rect">
+            <a:avLst/>
+          </a:prstGeom>
+          <a:noFill/>
+          <a:ln/>
+        </p:spPr>
+        <p:txBody>
+          <a:bodyPr wrap="square" lIns="0" tIns="0" rIns="0" bIns="0" rtlCol="0" anchor="ctr"/>
+          <a:lstStyle/>
+          <a:p>
+            <a:pPr indent="0" marL="0">
+              <a:buNone/>
+            </a:pPr>
+            <a:r>
+              <a:rPr lang="en-US" sz="2000" dirty="0">
+                <a:solidFill>
+                  <a:srgbClr val="FFFFFF"/>
+                </a:solidFill>
+              </a:rPr>
+              <a:t>valori mancanti</a:t>
+            </a:r>
+            <a:endParaRPr lang="en-US" sz="2000" dirty="0"/>
+          </a:p>
+        </p:txBody>
+      </p:sp>
+      <p:sp>
+        <p:nvSpPr>
+          <p:cNvPr id="13" name="Text 11"/>
+          <p:cNvSpPr txBox="1"/>
+          <p:nvPr/>
+        </p:nvSpPr>
+        <p:spPr>
+          <a:xfrm>
+            <a:off x="548640" y="5349240"/>
             <a:ext cx="11064240" cy="457200"/>
           </a:xfrm>
           <a:prstGeom prst="rect">
@@ -3400,7 +3186,7 @@
                   <a:srgbClr val="0F4C5C"/>
                 </a:solidFill>
               </a:rPr>
-              <a:t>Il codice non sa che è un errore. Lo sai tu, perché conosci i dati.</a:t>
+              <a:t>Stesso codice, stesse funzioni, nessun errore. Solo il conteggio dei mancanti ti salva.</a:t>
             </a:r>
             <a:endParaRPr lang="en-US" sz="1800" dirty="0"/>
           </a:p>
@@ -3508,7 +3294,7 @@
                   <a:srgbClr val="0F4C5C"/>
                 </a:solidFill>
               </a:rPr>
-              <a:t>Le scorciatoie automatiche</a:t>
+              <a:t>Un fatturato di 24 milioni?</a:t>
             </a:r>
             <a:endParaRPr lang="en-US" sz="3600" dirty="0"/>
           </a:p>
@@ -3516,115 +3302,18 @@
       </p:sp>
       <p:sp>
         <p:nvSpPr>
-          <p:cNvPr id="3" name="card-code"/>
+          <p:cNvPr id="3" name="Shape 1"/>
           <p:cNvSpPr/>
           <p:nvPr/>
         </p:nvSpPr>
         <p:spPr>
           <a:xfrm>
             <a:off x="548640" y="1737360"/>
-            <a:ext cx="6035040" cy="1188720"/>
+            <a:ext cx="3657600" cy="2377440"/>
           </a:xfrm>
           <a:prstGeom prst="roundRect">
             <a:avLst>
-              <a:gd name="adj" fmla="val 9231"/>
-            </a:avLst>
-          </a:prstGeom>
-          <a:solidFill>
-            <a:srgbClr val="1F2A30"/>
-          </a:solidFill>
-          <a:ln/>
-        </p:spPr>
-      </p:sp>
-      <p:sp>
-        <p:nvSpPr>
-          <p:cNvPr id="4" name="Text 2"/>
-          <p:cNvSpPr txBox="1"/>
-          <p:nvPr/>
-        </p:nvSpPr>
-        <p:spPr>
-          <a:xfrm>
-            <a:off x="777240" y="1874520"/>
-            <a:ext cx="1828800" cy="274320"/>
-          </a:xfrm>
-          <a:prstGeom prst="rect">
-            <a:avLst/>
-          </a:prstGeom>
-          <a:noFill/>
-          <a:ln/>
-        </p:spPr>
-        <p:txBody>
-          <a:bodyPr wrap="square" lIns="0" tIns="0" rIns="0" bIns="0" rtlCol="0" anchor="ctr"/>
-          <a:lstStyle/>
-          <a:p>
-            <a:pPr indent="0" marL="0">
-              <a:buNone/>
-            </a:pPr>
-            <a:r>
-              <a:rPr lang="en-US" sz="1100" b="1" spc="200" kern="0" dirty="0">
-                <a:solidFill>
-                  <a:srgbClr val="E09F3E"/>
-                </a:solidFill>
-              </a:rPr>
-              <a:t>PYTHON</a:t>
-            </a:r>
-            <a:endParaRPr lang="en-US" sz="1100" dirty="0"/>
-          </a:p>
-        </p:txBody>
-      </p:sp>
-      <p:sp>
-        <p:nvSpPr>
-          <p:cNvPr id="5" name="Text 3"/>
-          <p:cNvSpPr txBox="1"/>
-          <p:nvPr/>
-        </p:nvSpPr>
-        <p:spPr>
-          <a:xfrm>
-            <a:off x="777240" y="2194560"/>
-            <a:ext cx="5577840" cy="594360"/>
-          </a:xfrm>
-          <a:prstGeom prst="rect">
-            <a:avLst/>
-          </a:prstGeom>
-          <a:noFill/>
-          <a:ln/>
-        </p:spPr>
-        <p:txBody>
-          <a:bodyPr wrap="square" lIns="0" tIns="0" rIns="0" bIns="0" rtlCol="0" anchor="t"/>
-          <a:lstStyle/>
-          <a:p>
-            <a:pPr indent="0" marL="0">
-              <a:buNone/>
-            </a:pPr>
-            <a:r>
-              <a:rPr lang="en-US" sz="1700" dirty="0">
-                <a:solidFill>
-                  <a:srgbClr val="FFFFFF"/>
-                </a:solidFill>
-                <a:latin typeface="Courier New" pitchFamily="34" charset="0"/>
-                <a:ea typeface="Courier New" pitchFamily="34" charset="-122"/>
-                <a:cs typeface="Courier New" pitchFamily="34" charset="-120"/>
-              </a:rPr>
-              <a:t>df["regione"].str.strip().str.title()</a:t>
-            </a:r>
-            <a:endParaRPr lang="en-US" sz="1700" dirty="0"/>
-          </a:p>
-        </p:txBody>
-      </p:sp>
-      <p:sp>
-        <p:nvSpPr>
-          <p:cNvPr id="6" name="card-out"/>
-          <p:cNvSpPr/>
-          <p:nvPr/>
-        </p:nvSpPr>
-        <p:spPr>
-          <a:xfrm>
-            <a:off x="548640" y="3108960"/>
-            <a:ext cx="6035040" cy="1737360"/>
-          </a:xfrm>
-          <a:prstGeom prst="roundRect">
-            <a:avLst>
-              <a:gd name="adj" fmla="val 6316"/>
+              <a:gd name="adj" fmla="val 4615"/>
             </a:avLst>
           </a:prstGeom>
           <a:solidFill>
@@ -3635,14 +3324,108 @@
       </p:sp>
       <p:sp>
         <p:nvSpPr>
+          <p:cNvPr id="4" name="Text 2"/>
+          <p:cNvSpPr txBox="1"/>
+          <p:nvPr/>
+        </p:nvSpPr>
+        <p:spPr>
+          <a:xfrm>
+            <a:off x="868680" y="2011680"/>
+            <a:ext cx="3017520" cy="1005840"/>
+          </a:xfrm>
+          <a:prstGeom prst="rect">
+            <a:avLst/>
+          </a:prstGeom>
+          <a:noFill/>
+          <a:ln/>
+        </p:spPr>
+        <p:txBody>
+          <a:bodyPr wrap="square" lIns="0" tIns="0" rIns="0" bIns="0" rtlCol="0" anchor="ctr"/>
+          <a:lstStyle/>
+          <a:p>
+            <a:pPr indent="0" marL="0">
+              <a:buNone/>
+            </a:pPr>
+            <a:r>
+              <a:rPr lang="en-US" sz="5400" b="1" dirty="0">
+                <a:solidFill>
+                  <a:srgbClr val="0F4C5C"/>
+                </a:solidFill>
+              </a:rPr>
+              <a:t>1.407</a:t>
+            </a:r>
+            <a:endParaRPr lang="en-US" sz="5400" dirty="0"/>
+          </a:p>
+        </p:txBody>
+      </p:sp>
+      <p:sp>
+        <p:nvSpPr>
+          <p:cNvPr id="5" name="Text 3"/>
+          <p:cNvSpPr txBox="1"/>
+          <p:nvPr/>
+        </p:nvSpPr>
+        <p:spPr>
+          <a:xfrm>
+            <a:off x="868680" y="3154680"/>
+            <a:ext cx="3017520" cy="457200"/>
+          </a:xfrm>
+          <a:prstGeom prst="rect">
+            <a:avLst/>
+          </a:prstGeom>
+          <a:noFill/>
+          <a:ln/>
+        </p:spPr>
+        <p:txBody>
+          <a:bodyPr wrap="square" lIns="0" tIns="0" rIns="0" bIns="0" rtlCol="0" anchor="ctr"/>
+          <a:lstStyle/>
+          <a:p>
+            <a:pPr indent="0" marL="0">
+              <a:buNone/>
+            </a:pPr>
+            <a:r>
+              <a:rPr lang="en-US" sz="1800" dirty="0">
+                <a:solidFill>
+                  <a:srgbClr val="0F4C5C"/>
+                </a:solidFill>
+              </a:rPr>
+              <a:t>fatturato mediano</a:t>
+            </a:r>
+            <a:endParaRPr lang="en-US" sz="1800" dirty="0"/>
+          </a:p>
+        </p:txBody>
+      </p:sp>
+      <p:sp>
+        <p:nvSpPr>
+          <p:cNvPr id="6" name="Shape 4"/>
+          <p:cNvSpPr/>
+          <p:nvPr/>
+        </p:nvSpPr>
+        <p:spPr>
+          <a:xfrm>
+            <a:off x="4480560" y="1737360"/>
+            <a:ext cx="3657600" cy="2377440"/>
+          </a:xfrm>
+          <a:prstGeom prst="roundRect">
+            <a:avLst>
+              <a:gd name="adj" fmla="val 4615"/>
+            </a:avLst>
+          </a:prstGeom>
+          <a:solidFill>
+            <a:srgbClr val="0F4C5C"/>
+          </a:solidFill>
+          <a:ln/>
+        </p:spPr>
+      </p:sp>
+      <p:sp>
+        <p:nvSpPr>
           <p:cNvPr id="7" name="Text 5"/>
           <p:cNvSpPr txBox="1"/>
           <p:nvPr/>
         </p:nvSpPr>
         <p:spPr>
           <a:xfrm>
-            <a:off x="777240" y="3246120"/>
-            <a:ext cx="1828800" cy="274320"/>
+            <a:off x="4800600" y="2011680"/>
+            <a:ext cx="3017520" cy="1005840"/>
           </a:xfrm>
           <a:prstGeom prst="rect">
             <a:avLst/>
@@ -3658,14 +3441,14 @@
               <a:buNone/>
             </a:pPr>
             <a:r>
-              <a:rPr lang="en-US" sz="1100" b="1" spc="200" kern="0" dirty="0">
-                <a:solidFill>
-                  <a:srgbClr val="5C6F7B"/>
-                </a:solidFill>
-              </a:rPr>
-              <a:t>OUTPUT</a:t>
-            </a:r>
-            <a:endParaRPr lang="en-US" sz="1100" dirty="0"/>
+              <a:rPr lang="en-US" sz="4000" b="1" dirty="0">
+                <a:solidFill>
+                  <a:srgbClr val="FFFFFF"/>
+                </a:solidFill>
+              </a:rPr>
+              <a:t>24.586.100</a:t>
+            </a:r>
+            <a:endParaRPr lang="en-US" sz="4000" dirty="0"/>
           </a:p>
         </p:txBody>
       </p:sp>
@@ -3677,68 +3460,31 @@
         </p:nvSpPr>
         <p:spPr>
           <a:xfrm>
-            <a:off x="777240" y="3566160"/>
-            <a:ext cx="5577840" cy="1143000"/>
-          </a:xfrm>
-          <a:prstGeom prst="rect">
-            <a:avLst/>
-          </a:prstGeom>
-          <a:noFill/>
-          <a:ln/>
-        </p:spPr>
-        <p:txBody>
-          <a:bodyPr wrap="square" lIns="0" tIns="0" rIns="0" bIns="0" rtlCol="0" anchor="t"/>
-          <a:lstStyle/>
-          <a:p>
-            <a:pPr indent="0" marL="0">
-              <a:buNone/>
-            </a:pPr>
-            <a:r>
-              <a:rPr lang="en-US" sz="1700" dirty="0">
-                <a:solidFill>
-                  <a:srgbClr val="1F2A30"/>
-                </a:solidFill>
-                <a:latin typeface="Courier New" pitchFamily="34" charset="0"/>
-                <a:ea typeface="Courier New" pitchFamily="34" charset="-122"/>
-                <a:cs typeface="Courier New" pitchFamily="34" charset="-120"/>
-              </a:rPr>
-              <a:t>Valle d'Aosta  →  Valle D'Aosta</a:t>
-            </a:r>
-            <a:endParaRPr lang="en-US" sz="1700" dirty="0"/>
-          </a:p>
-          <a:p>
-            <a:pPr indent="0" marL="0">
-              <a:buNone/>
-            </a:pPr>
-            <a:r>
-              <a:rPr lang="en-US" sz="1700" dirty="0">
-                <a:solidFill>
-                  <a:srgbClr val="1F2A30"/>
-                </a:solidFill>
-                <a:latin typeface="Courier New" pitchFamily="34" charset="0"/>
-                <a:ea typeface="Courier New" pitchFamily="34" charset="-122"/>
-                <a:cs typeface="Courier New" pitchFamily="34" charset="-120"/>
-              </a:rPr>
-              <a:t>Emilia Romagna →  Emilia Romagna</a:t>
-            </a:r>
-            <a:endParaRPr lang="en-US" sz="1700" dirty="0"/>
-          </a:p>
-          <a:p>
-            <a:pPr indent="0" marL="0">
-              <a:buNone/>
-            </a:pPr>
-            <a:r>
-              <a:rPr lang="en-US" sz="1700" dirty="0">
-                <a:solidFill>
-                  <a:srgbClr val="1F2A30"/>
-                </a:solidFill>
-                <a:latin typeface="Courier New" pitchFamily="34" charset="0"/>
-                <a:ea typeface="Courier New" pitchFamily="34" charset="-122"/>
-                <a:cs typeface="Courier New" pitchFamily="34" charset="-120"/>
-              </a:rPr>
-              <a:t>regioni: 21</a:t>
-            </a:r>
-            <a:endParaRPr lang="en-US" sz="1700" dirty="0"/>
+            <a:off x="4800600" y="3154680"/>
+            <a:ext cx="3017520" cy="457200"/>
+          </a:xfrm>
+          <a:prstGeom prst="rect">
+            <a:avLst/>
+          </a:prstGeom>
+          <a:noFill/>
+          <a:ln/>
+        </p:spPr>
+        <p:txBody>
+          <a:bodyPr wrap="square" lIns="0" tIns="0" rIns="0" bIns="0" rtlCol="0" anchor="ctr"/>
+          <a:lstStyle/>
+          <a:p>
+            <a:pPr indent="0" marL="0">
+              <a:buNone/>
+            </a:pPr>
+            <a:r>
+              <a:rPr lang="en-US" sz="1800" dirty="0">
+                <a:solidFill>
+                  <a:srgbClr val="FFFFFF"/>
+                </a:solidFill>
+              </a:rPr>
+              <a:t>fatturato massimo</a:t>
+            </a:r>
+            <a:endParaRPr lang="en-US" sz="1800" dirty="0"/>
           </a:p>
         </p:txBody>
       </p:sp>
@@ -3750,8 +3496,8 @@
         </p:nvSpPr>
         <p:spPr>
           <a:xfrm>
-            <a:off x="7040880" y="1828800"/>
-            <a:ext cx="4572000" cy="3840480"/>
+            <a:off x="8503920" y="1828800"/>
+            <a:ext cx="3108960" cy="4114800"/>
           </a:xfrm>
           <a:prstGeom prst="rect">
             <a:avLst/>
@@ -3770,14 +3516,14 @@
               <a:buNone/>
             </a:pPr>
             <a:r>
-              <a:rPr lang="en-US" sz="1900" dirty="0">
+              <a:rPr lang="en-US" sz="1700" dirty="0">
                 <a:solidFill>
                   <a:srgbClr val="1F2A30"/>
                 </a:solidFill>
               </a:rPr>
-              <a:t>.title() sistema le maiuscole, ma rompe Valle d'Aosta e non aggiunge il trattino.</a:t>
-            </a:r>
-            <a:endParaRPr lang="en-US" sz="1900" dirty="0"/>
+              <a:t>Cinque valori enormi, poi un salto netto.</a:t>
+            </a:r>
+            <a:endParaRPr lang="en-US" sz="1700" dirty="0"/>
           </a:p>
           <a:p>
             <a:pPr indent="0" marL="0">
@@ -3787,14 +3533,14 @@
               <a:buNone/>
             </a:pPr>
             <a:r>
-              <a:rPr lang="en-US" sz="1900" dirty="0">
+              <a:rPr lang="en-US" sz="1700" dirty="0">
                 <a:solidFill>
                   <a:srgbClr val="1F2A30"/>
                 </a:solidFill>
               </a:rPr>
-              <a:t>Più sicuro: strip() e poi correzioni esplicite con replace().</a:t>
-            </a:r>
-            <a:endParaRPr lang="en-US" sz="1900" dirty="0"/>
+              <a:t>Negli altri anni la stessa impresa fattura circa mille volte meno: inseriti in euro, non in migliaia.</a:t>
+            </a:r>
+            <a:endParaRPr lang="en-US" sz="1700" dirty="0"/>
           </a:p>
           <a:p>
             <a:pPr indent="0" marL="0">
@@ -3804,14 +3550,50 @@
               <a:buNone/>
             </a:pPr>
             <a:r>
-              <a:rPr lang="en-US" sz="1900" b="1" dirty="0">
+              <a:rPr lang="en-US" sz="1700" b="1" dirty="0">
                 <a:solidFill>
                   <a:srgbClr val="0F4C5C"/>
                 </a:solidFill>
               </a:rPr>
-              <a:t>Ce ne accorgeremo nella L5, quando uniremo i dati delle regioni.</a:t>
-            </a:r>
-            <a:endParaRPr lang="en-US" sz="1900" dirty="0"/>
+              <a:t>Decisione: soglia 200.000, divisi per 1.000.</a:t>
+            </a:r>
+            <a:endParaRPr lang="en-US" sz="1700" dirty="0"/>
+          </a:p>
+        </p:txBody>
+      </p:sp>
+      <p:sp>
+        <p:nvSpPr>
+          <p:cNvPr id="10" name="Text 8"/>
+          <p:cNvSpPr txBox="1"/>
+          <p:nvPr/>
+        </p:nvSpPr>
+        <p:spPr>
+          <a:xfrm>
+            <a:off x="548640" y="4572000"/>
+            <a:ext cx="11064240" cy="457200"/>
+          </a:xfrm>
+          <a:prstGeom prst="rect">
+            <a:avLst/>
+          </a:prstGeom>
+          <a:noFill/>
+          <a:ln/>
+        </p:spPr>
+        <p:txBody>
+          <a:bodyPr wrap="square" lIns="0" tIns="0" rIns="0" bIns="0" rtlCol="0" anchor="ctr"/>
+          <a:lstStyle/>
+          <a:p>
+            <a:pPr indent="0" marL="0">
+              <a:buNone/>
+            </a:pPr>
+            <a:r>
+              <a:rPr lang="en-US" sz="1800" i="1" dirty="0">
+                <a:solidFill>
+                  <a:srgbClr val="0F4C5C"/>
+                </a:solidFill>
+              </a:rPr>
+              <a:t>Il codice non sa che è un errore. Lo sai tu, perché conosci i dati.</a:t>
+            </a:r>
+            <a:endParaRPr lang="en-US" sz="1800" dirty="0"/>
           </a:p>
         </p:txBody>
       </p:sp>
@@ -3917,6 +3699,415 @@
                   <a:srgbClr val="0F4C5C"/>
                 </a:solidFill>
               </a:rPr>
+              <a:t>Le scorciatoie automatiche</a:t>
+            </a:r>
+            <a:endParaRPr lang="en-US" sz="3600" dirty="0"/>
+          </a:p>
+        </p:txBody>
+      </p:sp>
+      <p:sp>
+        <p:nvSpPr>
+          <p:cNvPr id="3" name="card-code"/>
+          <p:cNvSpPr/>
+          <p:nvPr/>
+        </p:nvSpPr>
+        <p:spPr>
+          <a:xfrm>
+            <a:off x="548640" y="1737360"/>
+            <a:ext cx="6035040" cy="1188720"/>
+          </a:xfrm>
+          <a:prstGeom prst="roundRect">
+            <a:avLst>
+              <a:gd name="adj" fmla="val 9231"/>
+            </a:avLst>
+          </a:prstGeom>
+          <a:solidFill>
+            <a:srgbClr val="1F2A30"/>
+          </a:solidFill>
+          <a:ln/>
+        </p:spPr>
+      </p:sp>
+      <p:sp>
+        <p:nvSpPr>
+          <p:cNvPr id="4" name="Text 2"/>
+          <p:cNvSpPr txBox="1"/>
+          <p:nvPr/>
+        </p:nvSpPr>
+        <p:spPr>
+          <a:xfrm>
+            <a:off x="777240" y="1874520"/>
+            <a:ext cx="1828800" cy="274320"/>
+          </a:xfrm>
+          <a:prstGeom prst="rect">
+            <a:avLst/>
+          </a:prstGeom>
+          <a:noFill/>
+          <a:ln/>
+        </p:spPr>
+        <p:txBody>
+          <a:bodyPr wrap="square" lIns="0" tIns="0" rIns="0" bIns="0" rtlCol="0" anchor="ctr"/>
+          <a:lstStyle/>
+          <a:p>
+            <a:pPr indent="0" marL="0">
+              <a:buNone/>
+            </a:pPr>
+            <a:r>
+              <a:rPr lang="en-US" sz="1100" b="1" spc="200" kern="0" dirty="0">
+                <a:solidFill>
+                  <a:srgbClr val="E09F3E"/>
+                </a:solidFill>
+              </a:rPr>
+              <a:t>PYTHON</a:t>
+            </a:r>
+            <a:endParaRPr lang="en-US" sz="1100" dirty="0"/>
+          </a:p>
+        </p:txBody>
+      </p:sp>
+      <p:sp>
+        <p:nvSpPr>
+          <p:cNvPr id="5" name="Text 3"/>
+          <p:cNvSpPr txBox="1"/>
+          <p:nvPr/>
+        </p:nvSpPr>
+        <p:spPr>
+          <a:xfrm>
+            <a:off x="777240" y="2194560"/>
+            <a:ext cx="5577840" cy="594360"/>
+          </a:xfrm>
+          <a:prstGeom prst="rect">
+            <a:avLst/>
+          </a:prstGeom>
+          <a:noFill/>
+          <a:ln/>
+        </p:spPr>
+        <p:txBody>
+          <a:bodyPr wrap="square" lIns="0" tIns="0" rIns="0" bIns="0" rtlCol="0" anchor="t"/>
+          <a:lstStyle/>
+          <a:p>
+            <a:pPr indent="0" marL="0">
+              <a:buNone/>
+            </a:pPr>
+            <a:r>
+              <a:rPr lang="en-US" sz="1700" dirty="0">
+                <a:solidFill>
+                  <a:srgbClr val="FFFFFF"/>
+                </a:solidFill>
+                <a:latin typeface="Courier New" pitchFamily="34" charset="0"/>
+                <a:ea typeface="Courier New" pitchFamily="34" charset="-122"/>
+                <a:cs typeface="Courier New" pitchFamily="34" charset="-120"/>
+              </a:rPr>
+              <a:t>df["regione"].str.strip().str.title()</a:t>
+            </a:r>
+            <a:endParaRPr lang="en-US" sz="1700" dirty="0"/>
+          </a:p>
+        </p:txBody>
+      </p:sp>
+      <p:sp>
+        <p:nvSpPr>
+          <p:cNvPr id="6" name="card-out"/>
+          <p:cNvSpPr/>
+          <p:nvPr/>
+        </p:nvSpPr>
+        <p:spPr>
+          <a:xfrm>
+            <a:off x="548640" y="3108960"/>
+            <a:ext cx="6035040" cy="1737360"/>
+          </a:xfrm>
+          <a:prstGeom prst="roundRect">
+            <a:avLst>
+              <a:gd name="adj" fmla="val 6316"/>
+            </a:avLst>
+          </a:prstGeom>
+          <a:solidFill>
+            <a:srgbClr val="EEF3F4"/>
+          </a:solidFill>
+          <a:ln/>
+        </p:spPr>
+      </p:sp>
+      <p:sp>
+        <p:nvSpPr>
+          <p:cNvPr id="7" name="Text 5"/>
+          <p:cNvSpPr txBox="1"/>
+          <p:nvPr/>
+        </p:nvSpPr>
+        <p:spPr>
+          <a:xfrm>
+            <a:off x="777240" y="3246120"/>
+            <a:ext cx="1828800" cy="274320"/>
+          </a:xfrm>
+          <a:prstGeom prst="rect">
+            <a:avLst/>
+          </a:prstGeom>
+          <a:noFill/>
+          <a:ln/>
+        </p:spPr>
+        <p:txBody>
+          <a:bodyPr wrap="square" lIns="0" tIns="0" rIns="0" bIns="0" rtlCol="0" anchor="ctr"/>
+          <a:lstStyle/>
+          <a:p>
+            <a:pPr indent="0" marL="0">
+              <a:buNone/>
+            </a:pPr>
+            <a:r>
+              <a:rPr lang="en-US" sz="1100" b="1" spc="200" kern="0" dirty="0">
+                <a:solidFill>
+                  <a:srgbClr val="5C6F7B"/>
+                </a:solidFill>
+              </a:rPr>
+              <a:t>OUTPUT</a:t>
+            </a:r>
+            <a:endParaRPr lang="en-US" sz="1100" dirty="0"/>
+          </a:p>
+        </p:txBody>
+      </p:sp>
+      <p:sp>
+        <p:nvSpPr>
+          <p:cNvPr id="8" name="Text 6"/>
+          <p:cNvSpPr txBox="1"/>
+          <p:nvPr/>
+        </p:nvSpPr>
+        <p:spPr>
+          <a:xfrm>
+            <a:off x="777240" y="3566160"/>
+            <a:ext cx="5577840" cy="1143000"/>
+          </a:xfrm>
+          <a:prstGeom prst="rect">
+            <a:avLst/>
+          </a:prstGeom>
+          <a:noFill/>
+          <a:ln/>
+        </p:spPr>
+        <p:txBody>
+          <a:bodyPr wrap="square" lIns="0" tIns="0" rIns="0" bIns="0" rtlCol="0" anchor="t"/>
+          <a:lstStyle/>
+          <a:p>
+            <a:pPr indent="0" marL="0">
+              <a:buNone/>
+            </a:pPr>
+            <a:r>
+              <a:rPr lang="en-US" sz="1700" dirty="0">
+                <a:solidFill>
+                  <a:srgbClr val="1F2A30"/>
+                </a:solidFill>
+                <a:latin typeface="Courier New" pitchFamily="34" charset="0"/>
+                <a:ea typeface="Courier New" pitchFamily="34" charset="-122"/>
+                <a:cs typeface="Courier New" pitchFamily="34" charset="-120"/>
+              </a:rPr>
+              <a:t>Valle d'Aosta  →  Valle D'Aosta</a:t>
+            </a:r>
+            <a:endParaRPr lang="en-US" sz="1700" dirty="0"/>
+          </a:p>
+          <a:p>
+            <a:pPr indent="0" marL="0">
+              <a:buNone/>
+            </a:pPr>
+            <a:r>
+              <a:rPr lang="en-US" sz="1700" dirty="0">
+                <a:solidFill>
+                  <a:srgbClr val="1F2A30"/>
+                </a:solidFill>
+                <a:latin typeface="Courier New" pitchFamily="34" charset="0"/>
+                <a:ea typeface="Courier New" pitchFamily="34" charset="-122"/>
+                <a:cs typeface="Courier New" pitchFamily="34" charset="-120"/>
+              </a:rPr>
+              <a:t>Emilia Romagna →  Emilia Romagna</a:t>
+            </a:r>
+            <a:endParaRPr lang="en-US" sz="1700" dirty="0"/>
+          </a:p>
+          <a:p>
+            <a:pPr indent="0" marL="0">
+              <a:buNone/>
+            </a:pPr>
+            <a:r>
+              <a:rPr lang="en-US" sz="1700" dirty="0">
+                <a:solidFill>
+                  <a:srgbClr val="1F2A30"/>
+                </a:solidFill>
+                <a:latin typeface="Courier New" pitchFamily="34" charset="0"/>
+                <a:ea typeface="Courier New" pitchFamily="34" charset="-122"/>
+                <a:cs typeface="Courier New" pitchFamily="34" charset="-120"/>
+              </a:rPr>
+              <a:t>regioni: 21</a:t>
+            </a:r>
+            <a:endParaRPr lang="en-US" sz="1700" dirty="0"/>
+          </a:p>
+        </p:txBody>
+      </p:sp>
+      <p:sp>
+        <p:nvSpPr>
+          <p:cNvPr id="9" name="Text 7"/>
+          <p:cNvSpPr txBox="1"/>
+          <p:nvPr/>
+        </p:nvSpPr>
+        <p:spPr>
+          <a:xfrm>
+            <a:off x="7040880" y="1828800"/>
+            <a:ext cx="4572000" cy="3840480"/>
+          </a:xfrm>
+          <a:prstGeom prst="rect">
+            <a:avLst/>
+          </a:prstGeom>
+          <a:noFill/>
+          <a:ln/>
+        </p:spPr>
+        <p:txBody>
+          <a:bodyPr wrap="square" lIns="0" tIns="0" rIns="0" bIns="0" rtlCol="0" anchor="t"/>
+          <a:lstStyle/>
+          <a:p>
+            <a:pPr indent="0" marL="0">
+              <a:spcAft>
+                <a:spcPts val="1000"/>
+              </a:spcAft>
+              <a:buNone/>
+            </a:pPr>
+            <a:r>
+              <a:rPr lang="en-US" sz="1900" dirty="0">
+                <a:solidFill>
+                  <a:srgbClr val="1F2A30"/>
+                </a:solidFill>
+              </a:rPr>
+              <a:t>.title() sistema le maiuscole, ma rompe Valle d'Aosta e non aggiunge il trattino.</a:t>
+            </a:r>
+            <a:endParaRPr lang="en-US" sz="1900" dirty="0"/>
+          </a:p>
+          <a:p>
+            <a:pPr indent="0" marL="0">
+              <a:spcAft>
+                <a:spcPts val="1000"/>
+              </a:spcAft>
+              <a:buNone/>
+            </a:pPr>
+            <a:r>
+              <a:rPr lang="en-US" sz="1900" dirty="0">
+                <a:solidFill>
+                  <a:srgbClr val="1F2A30"/>
+                </a:solidFill>
+              </a:rPr>
+              <a:t>Più sicuro: strip() e poi correzioni esplicite con replace().</a:t>
+            </a:r>
+            <a:endParaRPr lang="en-US" sz="1900" dirty="0"/>
+          </a:p>
+          <a:p>
+            <a:pPr indent="0" marL="0">
+              <a:spcAft>
+                <a:spcPts val="1000"/>
+              </a:spcAft>
+              <a:buNone/>
+            </a:pPr>
+            <a:r>
+              <a:rPr lang="en-US" sz="1900" b="1" dirty="0">
+                <a:solidFill>
+                  <a:srgbClr val="0F4C5C"/>
+                </a:solidFill>
+              </a:rPr>
+              <a:t>Ce ne accorgeremo nella L5, quando uniremo i dati delle regioni.</a:t>
+            </a:r>
+            <a:endParaRPr lang="en-US" sz="1900" dirty="0"/>
+          </a:p>
+        </p:txBody>
+      </p:sp>
+      <p:sp>
+        <p:nvSpPr>
+          <p:cNvPr id="25" name="Slide Number Placeholder 0"/>
+          <p:cNvSpPr>
+            <a:spLocks noGrp="1"/>
+          </p:cNvSpPr>
+          <p:nvPr>
+            <p:ph type="sldNum" sz="quarter" idx="4294967295"/>
+          </p:nvPr>
+        </p:nvSpPr>
+        <p:spPr>
+          <a:xfrm>
+            <a:off x="11155680" y="6400800"/>
+            <a:ext cx="457200" cy="274320"/>
+          </a:xfrm>
+          <a:prstGeom prst="rect">
+            <a:avLst/>
+          </a:prstGeom>
+          <a:extLst>
+            <a:ext uri="{C572A759-6A51-4108-AA02-DFA0A04FC94B}">
+              <ma14:wrappingTextBoxFlag xmlns:ma14="http://schemas.microsoft.com/office/mac/drawingml/2011/main" val="0"/>
+            </a:ext>
+          </a:extLst>
+        </p:spPr>
+        <p:txBody>
+          <a:bodyPr/>
+          <a:lstStyle>
+            <a:lvl1pPr>
+              <a:defRPr sz="1000">
+                <a:solidFill>
+                  <a:srgbClr val="5C6F7B"/>
+                </a:solidFill>
+              </a:defRPr>
+            </a:lvl1pPr>
+          </a:lstStyle>
+          <a:p>
+            <a:pPr algn="r"/>
+            <a:fld id="{F7021451-1387-4CA6-816F-3879F97B5CBC}" type="slidenum">
+              <a:rPr b="0" lang="en-US"/>
+              <a:t>13</a:t>
+            </a:fld>
+            <a:endParaRPr lang="en-US"/>
+          </a:p>
+        </p:txBody>
+      </p:sp>
+    </p:spTree>
+  </p:cSld>
+  <p:clrMapOvr>
+    <a:masterClrMapping/>
+  </p:clrMapOvr>
+</p:sld>
+</file>
+
+<file path=ppt/slides/slide14.xml><?xml version="1.0" encoding="utf-8"?>
+<p:sld xmlns:a="http://schemas.openxmlformats.org/drawingml/2006/main" xmlns:r="http://schemas.openxmlformats.org/officeDocument/2006/relationships" xmlns:p="http://schemas.openxmlformats.org/presentationml/2006/main">
+  <p:cSld name="Slide 14">
+    <p:spTree>
+      <p:nvGrpSpPr>
+        <p:cNvPr id="1" name=""/>
+        <p:cNvGrpSpPr/>
+        <p:nvPr/>
+      </p:nvGrpSpPr>
+      <p:grpSpPr>
+        <a:xfrm>
+          <a:off x="0" y="0"/>
+          <a:ext cx="0" cy="0"/>
+          <a:chOff x="0" y="0"/>
+          <a:chExt cx="0" cy="0"/>
+        </a:xfrm>
+      </p:grpSpPr>
+      <p:sp>
+        <p:nvSpPr>
+          <p:cNvPr id="2" name="Text 0"/>
+          <p:cNvSpPr/>
+          <p:nvPr>
+            <p:ph idx="100" type="title" hasCustomPrompt="1"/>
+          </p:nvPr>
+        </p:nvSpPr>
+        <p:spPr>
+          <a:xfrm>
+            <a:off x="548640" y="365760"/>
+            <a:ext cx="11064240" cy="822960"/>
+          </a:xfrm>
+          <a:prstGeom prst="rect">
+            <a:avLst/>
+          </a:prstGeom>
+          <a:noFill/>
+          <a:ln/>
+        </p:spPr>
+        <p:txBody>
+          <a:bodyPr wrap="square" lIns="0" tIns="0" rIns="0" bIns="0" rtlCol="0" anchor="ctr"/>
+          <a:lstStyle/>
+          <a:p>
+            <a:pPr algn="l" indent="0" marL="0">
+              <a:buNone/>
+            </a:pPr>
+            <a:r>
+              <a:rPr lang="en-US" sz="3600" b="1" dirty="0">
+                <a:solidFill>
+                  <a:srgbClr val="0F4C5C"/>
+                </a:solidFill>
+              </a:rPr>
               <a:t>Le nostre decisioni</a:t>
             </a:r>
             <a:endParaRPr lang="en-US" sz="3600" dirty="0"/>
@@ -3925,7 +4116,7 @@
       </p:sp>
       <p:graphicFrame>
         <p:nvGraphicFramePr>
-          <p:cNvPr id="14" name="Table 0"/>
+          <p:cNvPr id="15" name="Table 0"/>
           <p:cNvGraphicFramePr>
             <a:graphicFrameLocks noGrp="1"/>
           </p:cNvGraphicFramePr>
@@ -4530,7 +4721,7 @@
                             <a:srgbClr val="1F2A30"/>
                           </a:solidFill>
                         </a:rPr>
-                        <a:t>addetti negativi</a:t>
+                        <a:t>addetti negativi (IMP0253, 2019)</a:t>
                       </a:r>
                       <a:endParaRPr lang="en-US" sz="1600" dirty="0"/>
                     </a:p>
@@ -4567,7 +4758,7 @@
                             <a:srgbClr val="1F2A30"/>
                           </a:solidFill>
                         </a:rPr>
-                        <a:t>→ mancante</a:t>
+                        <a:t>corretto a 12, su indicazione del collega</a:t>
                       </a:r>
                       <a:endParaRPr lang="en-US" sz="1600" dirty="0"/>
                     </a:p>
@@ -4820,7 +5011,7 @@
             <a:pPr algn="r"/>
             <a:fld id="{F7021451-1387-4CA6-816F-3879F97B5CBC}" type="slidenum">
               <a:rPr b="0" lang="en-US"/>
-              <a:t>13</a:t>
+              <a:t>14</a:t>
             </a:fld>
             <a:endParaRPr lang="en-US"/>
           </a:p>
@@ -4834,9 +5025,9 @@
 </p:sld>
 </file>
 
-<file path=ppt/slides/slide14.xml><?xml version="1.0" encoding="utf-8"?>
+<file path=ppt/slides/slide15.xml><?xml version="1.0" encoding="utf-8"?>
 <p:sld xmlns:a="http://schemas.openxmlformats.org/drawingml/2006/main" xmlns:r="http://schemas.openxmlformats.org/officeDocument/2006/relationships" xmlns:p="http://schemas.openxmlformats.org/presentationml/2006/main">
-  <p:cSld name="Slide 14">
+  <p:cSld name="Slide 15">
     <p:spTree>
       <p:nvGrpSpPr>
         <p:cNvPr id="1" name=""/>
@@ -8210,83 +8401,668 @@
         </p:nvSpPr>
         <p:spPr>
           <a:xfrm>
-            <a:off x="731520" y="2194560"/>
-            <a:ext cx="10698480" cy="1280160"/>
-          </a:xfrm>
-          <a:prstGeom prst="rect">
-            <a:avLst/>
-          </a:prstGeom>
-          <a:noFill/>
-          <a:ln/>
-        </p:spPr>
-        <p:txBody>
-          <a:bodyPr wrap="square" lIns="0" tIns="0" rIns="0" bIns="0" rtlCol="0" anchor="b"/>
+            <a:off x="548640" y="365760"/>
+            <a:ext cx="11064240" cy="822960"/>
+          </a:xfrm>
+          <a:prstGeom prst="rect">
+            <a:avLst/>
+          </a:prstGeom>
+          <a:noFill/>
+          <a:ln/>
+        </p:spPr>
+        <p:txBody>
+          <a:bodyPr wrap="square" lIns="0" tIns="0" rIns="0" bIns="0" rtlCol="0" anchor="ctr"/>
           <a:lstStyle/>
           <a:p>
             <a:pPr algn="l" indent="0" marL="0">
               <a:buNone/>
             </a:pPr>
             <a:r>
-              <a:rPr lang="en-US" sz="5400" b="1" dirty="0">
+              <a:rPr lang="en-US" sz="3600" b="1" dirty="0">
+                <a:solidFill>
+                  <a:srgbClr val="0F4C5C"/>
+                </a:solidFill>
+              </a:rPr>
+              <a:t>Correggere una cella a mano</a:t>
+            </a:r>
+            <a:endParaRPr lang="en-US" sz="3600" dirty="0"/>
+          </a:p>
+        </p:txBody>
+      </p:sp>
+      <p:sp>
+        <p:nvSpPr>
+          <p:cNvPr id="3" name="Text 1"/>
+          <p:cNvSpPr txBox="1"/>
+          <p:nvPr/>
+        </p:nvSpPr>
+        <p:spPr>
+          <a:xfrm>
+            <a:off x="548640" y="1600200"/>
+            <a:ext cx="3657600" cy="457200"/>
+          </a:xfrm>
+          <a:prstGeom prst="rect">
+            <a:avLst/>
+          </a:prstGeom>
+          <a:noFill/>
+          <a:ln/>
+        </p:spPr>
+        <p:txBody>
+          <a:bodyPr wrap="square" lIns="0" tIns="0" rIns="0" bIns="0" rtlCol="0" anchor="ctr"/>
+          <a:lstStyle/>
+          <a:p>
+            <a:pPr indent="0" marL="0">
+              <a:buNone/>
+            </a:pPr>
+            <a:r>
+              <a:rPr lang="en-US" sz="2400" b="1" dirty="0">
+                <a:solidFill>
+                  <a:srgbClr val="0F4C5C"/>
+                </a:solidFill>
+              </a:rPr>
+              <a:t>In Excel</a:t>
+            </a:r>
+            <a:endParaRPr lang="en-US" sz="2400" dirty="0"/>
+          </a:p>
+        </p:txBody>
+      </p:sp>
+      <p:sp>
+        <p:nvSpPr>
+          <p:cNvPr id="4" name="Text 2"/>
+          <p:cNvSpPr txBox="1"/>
+          <p:nvPr/>
+        </p:nvSpPr>
+        <p:spPr>
+          <a:xfrm>
+            <a:off x="548640" y="2103120"/>
+            <a:ext cx="3657600" cy="1097280"/>
+          </a:xfrm>
+          <a:prstGeom prst="rect">
+            <a:avLst/>
+          </a:prstGeom>
+          <a:noFill/>
+          <a:ln/>
+        </p:spPr>
+        <p:txBody>
+          <a:bodyPr wrap="square" lIns="0" tIns="0" rIns="0" bIns="0" rtlCol="0" anchor="t"/>
+          <a:lstStyle/>
+          <a:p>
+            <a:pPr indent="0" marL="0">
+              <a:buNone/>
+            </a:pPr>
+            <a:r>
+              <a:rPr lang="en-US" sz="1800" dirty="0">
+                <a:solidFill>
+                  <a:srgbClr val="1F2A30"/>
+                </a:solidFill>
+              </a:rPr>
+              <a:t>clicchi sulla cella, scrivi 12, invio. Nessuno saprà mai che l'hai fatto.</a:t>
+            </a:r>
+            <a:endParaRPr lang="en-US" sz="1800" dirty="0"/>
+          </a:p>
+        </p:txBody>
+      </p:sp>
+      <p:sp>
+        <p:nvSpPr>
+          <p:cNvPr id="5" name="Text 3"/>
+          <p:cNvSpPr txBox="1"/>
+          <p:nvPr/>
+        </p:nvSpPr>
+        <p:spPr>
+          <a:xfrm>
+            <a:off x="4572000" y="1600200"/>
+            <a:ext cx="7040880" cy="457200"/>
+          </a:xfrm>
+          <a:prstGeom prst="rect">
+            <a:avLst/>
+          </a:prstGeom>
+          <a:noFill/>
+          <a:ln/>
+        </p:spPr>
+        <p:txBody>
+          <a:bodyPr wrap="square" lIns="0" tIns="0" rIns="0" bIns="0" rtlCol="0" anchor="ctr"/>
+          <a:lstStyle/>
+          <a:p>
+            <a:pPr indent="0" marL="0">
+              <a:buNone/>
+            </a:pPr>
+            <a:r>
+              <a:rPr lang="en-US" sz="2400" b="1" dirty="0">
+                <a:solidFill>
+                  <a:srgbClr val="0F4C5C"/>
+                </a:solidFill>
+              </a:rPr>
+              <a:t>In Python</a:t>
+            </a:r>
+            <a:endParaRPr lang="en-US" sz="2400" dirty="0"/>
+          </a:p>
+        </p:txBody>
+      </p:sp>
+      <p:sp>
+        <p:nvSpPr>
+          <p:cNvPr id="6" name="card-code"/>
+          <p:cNvSpPr/>
+          <p:nvPr/>
+        </p:nvSpPr>
+        <p:spPr>
+          <a:xfrm>
+            <a:off x="4572000" y="2103120"/>
+            <a:ext cx="7040880" cy="1828800"/>
+          </a:xfrm>
+          <a:prstGeom prst="roundRect">
+            <a:avLst>
+              <a:gd name="adj" fmla="val 6000"/>
+            </a:avLst>
+          </a:prstGeom>
+          <a:solidFill>
+            <a:srgbClr val="1F2A30"/>
+          </a:solidFill>
+          <a:ln/>
+        </p:spPr>
+      </p:sp>
+      <p:sp>
+        <p:nvSpPr>
+          <p:cNvPr id="7" name="Text 5"/>
+          <p:cNvSpPr txBox="1"/>
+          <p:nvPr/>
+        </p:nvSpPr>
+        <p:spPr>
+          <a:xfrm>
+            <a:off x="4800600" y="2240280"/>
+            <a:ext cx="1828800" cy="274320"/>
+          </a:xfrm>
+          <a:prstGeom prst="rect">
+            <a:avLst/>
+          </a:prstGeom>
+          <a:noFill/>
+          <a:ln/>
+        </p:spPr>
+        <p:txBody>
+          <a:bodyPr wrap="square" lIns="0" tIns="0" rIns="0" bIns="0" rtlCol="0" anchor="ctr"/>
+          <a:lstStyle/>
+          <a:p>
+            <a:pPr indent="0" marL="0">
+              <a:buNone/>
+            </a:pPr>
+            <a:r>
+              <a:rPr lang="en-US" sz="1100" b="1" spc="200" kern="0" dirty="0">
+                <a:solidFill>
+                  <a:srgbClr val="E09F3E"/>
+                </a:solidFill>
+              </a:rPr>
+              <a:t>PYTHON</a:t>
+            </a:r>
+            <a:endParaRPr lang="en-US" sz="1100" dirty="0"/>
+          </a:p>
+        </p:txBody>
+      </p:sp>
+      <p:sp>
+        <p:nvSpPr>
+          <p:cNvPr id="8" name="Text 6"/>
+          <p:cNvSpPr txBox="1"/>
+          <p:nvPr/>
+        </p:nvSpPr>
+        <p:spPr>
+          <a:xfrm>
+            <a:off x="4800600" y="2560320"/>
+            <a:ext cx="6583680" cy="1234440"/>
+          </a:xfrm>
+          <a:prstGeom prst="rect">
+            <a:avLst/>
+          </a:prstGeom>
+          <a:noFill/>
+          <a:ln/>
+        </p:spPr>
+        <p:txBody>
+          <a:bodyPr wrap="square" lIns="0" tIns="0" rIns="0" bIns="0" rtlCol="0" anchor="t"/>
+          <a:lstStyle/>
+          <a:p>
+            <a:pPr indent="0" marL="0">
+              <a:buNone/>
+            </a:pPr>
+            <a:r>
+              <a:rPr lang="en-US" sz="1600" dirty="0">
                 <a:solidFill>
                   <a:srgbClr val="FFFFFF"/>
                 </a:solidFill>
-              </a:rPr>
-              <a:t>Task: pulisci il dataset</a:t>
-            </a:r>
-            <a:endParaRPr lang="en-US" sz="5400" dirty="0"/>
-          </a:p>
-        </p:txBody>
-      </p:sp>
-      <p:sp>
-        <p:nvSpPr>
-          <p:cNvPr id="3" name="Text 0"/>
+                <a:latin typeface="Courier New" pitchFamily="34" charset="0"/>
+                <a:ea typeface="Courier New" pitchFamily="34" charset="-122"/>
+                <a:cs typeface="Courier New" pitchFamily="34" charset="-120"/>
+              </a:rPr>
+              <a:t>riga = ((df["cliente"] == "C042")</a:t>
+            </a:r>
+            <a:endParaRPr lang="en-US" sz="1600" dirty="0"/>
+          </a:p>
+          <a:p>
+            <a:pPr indent="0" marL="0">
+              <a:buNone/>
+            </a:pPr>
+            <a:r>
+              <a:rPr lang="en-US" sz="1600" dirty="0">
+                <a:solidFill>
+                  <a:srgbClr val="FFFFFF"/>
+                </a:solidFill>
+                <a:latin typeface="Courier New" pitchFamily="34" charset="0"/>
+                <a:ea typeface="Courier New" pitchFamily="34" charset="-122"/>
+                <a:cs typeface="Courier New" pitchFamily="34" charset="-120"/>
+              </a:rPr>
+              <a:t>        &amp; (df["anno"] == 2021))</a:t>
+            </a:r>
+            <a:endParaRPr lang="en-US" sz="1600" dirty="0"/>
+          </a:p>
+          <a:p>
+            <a:pPr indent="0" marL="0">
+              <a:buNone/>
+            </a:pPr>
+            <a:r>
+              <a:rPr lang="en-US" sz="1600" dirty="0">
+                <a:solidFill>
+                  <a:srgbClr val="FFFFFF"/>
+                </a:solidFill>
+                <a:latin typeface="Courier New" pitchFamily="34" charset="0"/>
+                <a:ea typeface="Courier New" pitchFamily="34" charset="-122"/>
+                <a:cs typeface="Courier New" pitchFamily="34" charset="-120"/>
+              </a:rPr>
+              <a:t>print(riga.sum())     # deve dare 1</a:t>
+            </a:r>
+            <a:endParaRPr lang="en-US" sz="1600" dirty="0"/>
+          </a:p>
+          <a:p>
+            <a:pPr indent="0" marL="0">
+              <a:buNone/>
+            </a:pPr>
+            <a:r>
+              <a:rPr lang="en-US" sz="1600" dirty="0">
+                <a:solidFill>
+                  <a:srgbClr val="FFFFFF"/>
+                </a:solidFill>
+                <a:latin typeface="Courier New" pitchFamily="34" charset="0"/>
+                <a:ea typeface="Courier New" pitchFamily="34" charset="-122"/>
+                <a:cs typeface="Courier New" pitchFamily="34" charset="-120"/>
+              </a:rPr>
+              <a:t>df.loc[riga, "ordini"] = 12</a:t>
+            </a:r>
+            <a:endParaRPr lang="en-US" sz="1600" dirty="0"/>
+          </a:p>
+        </p:txBody>
+      </p:sp>
+      <p:sp>
+        <p:nvSpPr>
+          <p:cNvPr id="9" name="Shape 7"/>
           <p:cNvSpPr/>
+          <p:nvPr/>
+        </p:nvSpPr>
+        <p:spPr>
+          <a:xfrm>
+            <a:off x="548640" y="4251960"/>
+            <a:ext cx="5440680" cy="1325880"/>
+          </a:xfrm>
+          <a:prstGeom prst="roundRect">
+            <a:avLst>
+              <a:gd name="adj" fmla="val 8276"/>
+            </a:avLst>
+          </a:prstGeom>
+          <a:solidFill>
+            <a:srgbClr val="EEF3F4"/>
+          </a:solidFill>
+          <a:ln/>
+        </p:spPr>
+      </p:sp>
+      <p:sp>
+        <p:nvSpPr>
+          <p:cNvPr id="10" name="Shape 8"/>
+          <p:cNvSpPr/>
+          <p:nvPr/>
+        </p:nvSpPr>
+        <p:spPr>
+          <a:xfrm>
+            <a:off x="822960" y="4553712"/>
+            <a:ext cx="685800" cy="685800"/>
+          </a:xfrm>
+          <a:prstGeom prst="ellipse">
+            <a:avLst/>
+          </a:prstGeom>
+          <a:solidFill>
+            <a:srgbClr val="E09F3E"/>
+          </a:solidFill>
+          <a:ln/>
+        </p:spPr>
+      </p:sp>
+      <p:sp>
+        <p:nvSpPr>
+          <p:cNvPr id="11" name="Text 9"/>
+          <p:cNvSpPr txBox="1"/>
+          <p:nvPr/>
+        </p:nvSpPr>
+        <p:spPr>
+          <a:xfrm>
+            <a:off x="822960" y="4553712"/>
+            <a:ext cx="685800" cy="685800"/>
+          </a:xfrm>
+          <a:prstGeom prst="rect">
+            <a:avLst/>
+          </a:prstGeom>
+          <a:noFill/>
+          <a:ln/>
+        </p:spPr>
+        <p:txBody>
+          <a:bodyPr wrap="square" lIns="0" tIns="0" rIns="0" bIns="0" rtlCol="0" anchor="ctr"/>
+          <a:lstStyle/>
+          <a:p>
+            <a:pPr algn="ctr" indent="0" marL="0">
+              <a:buNone/>
+            </a:pPr>
+            <a:r>
+              <a:rPr lang="en-US" sz="1950" b="1" dirty="0">
+                <a:solidFill>
+                  <a:srgbClr val="1F2A30"/>
+                </a:solidFill>
+              </a:rPr>
+              <a:t>1</a:t>
+            </a:r>
+            <a:endParaRPr lang="en-US" sz="1950" dirty="0"/>
+          </a:p>
+        </p:txBody>
+      </p:sp>
+      <p:sp>
+        <p:nvSpPr>
+          <p:cNvPr id="12" name="Text 10"/>
+          <p:cNvSpPr txBox="1"/>
+          <p:nvPr/>
+        </p:nvSpPr>
+        <p:spPr>
+          <a:xfrm>
+            <a:off x="1737360" y="4434840"/>
+            <a:ext cx="4069080" cy="457200"/>
+          </a:xfrm>
+          <a:prstGeom prst="rect">
+            <a:avLst/>
+          </a:prstGeom>
+          <a:noFill/>
+          <a:ln/>
+        </p:spPr>
+        <p:txBody>
+          <a:bodyPr wrap="square" lIns="0" tIns="0" rIns="0" bIns="0" rtlCol="0" anchor="ctr"/>
+          <a:lstStyle/>
+          <a:p>
+            <a:pPr indent="0" marL="0">
+              <a:buNone/>
+            </a:pPr>
+            <a:r>
+              <a:rPr lang="en-US" sz="2000" b="1" dirty="0">
+                <a:solidFill>
+                  <a:srgbClr val="1F2A30"/>
+                </a:solidFill>
+              </a:rPr>
+              <a:t>Sempre nel codice</a:t>
+            </a:r>
+            <a:endParaRPr lang="en-US" sz="2000" dirty="0"/>
+          </a:p>
+        </p:txBody>
+      </p:sp>
+      <p:sp>
+        <p:nvSpPr>
+          <p:cNvPr id="13" name="Text 11"/>
+          <p:cNvSpPr txBox="1"/>
+          <p:nvPr/>
+        </p:nvSpPr>
+        <p:spPr>
+          <a:xfrm>
+            <a:off x="1737360" y="4892040"/>
+            <a:ext cx="4069080" cy="502920"/>
+          </a:xfrm>
+          <a:prstGeom prst="rect">
+            <a:avLst/>
+          </a:prstGeom>
+          <a:noFill/>
+          <a:ln/>
+        </p:spPr>
+        <p:txBody>
+          <a:bodyPr wrap="square" lIns="0" tIns="0" rIns="0" bIns="0" rtlCol="0" anchor="ctr"/>
+          <a:lstStyle/>
+          <a:p>
+            <a:pPr indent="0" marL="0">
+              <a:buNone/>
+            </a:pPr>
+            <a:r>
+              <a:rPr lang="en-US" sz="1600" dirty="0">
+                <a:solidFill>
+                  <a:srgbClr val="5C6F7B"/>
+                </a:solidFill>
+              </a:rPr>
+              <a:t>la correzione resta scritta e si può rifare</a:t>
+            </a:r>
+            <a:endParaRPr lang="en-US" sz="1600" dirty="0"/>
+          </a:p>
+        </p:txBody>
+      </p:sp>
+      <p:sp>
+        <p:nvSpPr>
+          <p:cNvPr id="14" name="Shape 12"/>
+          <p:cNvSpPr/>
+          <p:nvPr/>
+        </p:nvSpPr>
+        <p:spPr>
+          <a:xfrm>
+            <a:off x="6172200" y="4251960"/>
+            <a:ext cx="5440680" cy="1325880"/>
+          </a:xfrm>
+          <a:prstGeom prst="roundRect">
+            <a:avLst>
+              <a:gd name="adj" fmla="val 8276"/>
+            </a:avLst>
+          </a:prstGeom>
+          <a:solidFill>
+            <a:srgbClr val="EEF3F4"/>
+          </a:solidFill>
+          <a:ln/>
+        </p:spPr>
+      </p:sp>
+      <p:sp>
+        <p:nvSpPr>
+          <p:cNvPr id="15" name="Shape 13"/>
+          <p:cNvSpPr/>
+          <p:nvPr/>
+        </p:nvSpPr>
+        <p:spPr>
+          <a:xfrm>
+            <a:off x="6446520" y="4553712"/>
+            <a:ext cx="685800" cy="685800"/>
+          </a:xfrm>
+          <a:prstGeom prst="ellipse">
+            <a:avLst/>
+          </a:prstGeom>
+          <a:solidFill>
+            <a:srgbClr val="E09F3E"/>
+          </a:solidFill>
+          <a:ln/>
+        </p:spPr>
+      </p:sp>
+      <p:sp>
+        <p:nvSpPr>
+          <p:cNvPr id="16" name="Text 14"/>
+          <p:cNvSpPr txBox="1"/>
+          <p:nvPr/>
+        </p:nvSpPr>
+        <p:spPr>
+          <a:xfrm>
+            <a:off x="6446520" y="4553712"/>
+            <a:ext cx="685800" cy="685800"/>
+          </a:xfrm>
+          <a:prstGeom prst="rect">
+            <a:avLst/>
+          </a:prstGeom>
+          <a:noFill/>
+          <a:ln/>
+        </p:spPr>
+        <p:txBody>
+          <a:bodyPr wrap="square" lIns="0" tIns="0" rIns="0" bIns="0" rtlCol="0" anchor="ctr"/>
+          <a:lstStyle/>
+          <a:p>
+            <a:pPr algn="ctr" indent="0" marL="0">
+              <a:buNone/>
+            </a:pPr>
+            <a:r>
+              <a:rPr lang="en-US" sz="1950" b="1" dirty="0">
+                <a:solidFill>
+                  <a:srgbClr val="1F2A30"/>
+                </a:solidFill>
+              </a:rPr>
+              <a:t>2</a:t>
+            </a:r>
+            <a:endParaRPr lang="en-US" sz="1950" dirty="0"/>
+          </a:p>
+        </p:txBody>
+      </p:sp>
+      <p:sp>
+        <p:nvSpPr>
+          <p:cNvPr id="17" name="Text 15"/>
+          <p:cNvSpPr txBox="1"/>
+          <p:nvPr/>
+        </p:nvSpPr>
+        <p:spPr>
+          <a:xfrm>
+            <a:off x="7360920" y="4434840"/>
+            <a:ext cx="4069080" cy="457200"/>
+          </a:xfrm>
+          <a:prstGeom prst="rect">
+            <a:avLst/>
+          </a:prstGeom>
+          <a:noFill/>
+          <a:ln/>
+        </p:spPr>
+        <p:txBody>
+          <a:bodyPr wrap="square" lIns="0" tIns="0" rIns="0" bIns="0" rtlCol="0" anchor="ctr"/>
+          <a:lstStyle/>
+          <a:p>
+            <a:pPr indent="0" marL="0">
+              <a:buNone/>
+            </a:pPr>
+            <a:r>
+              <a:rPr lang="en-US" sz="2000" b="1" dirty="0">
+                <a:solidFill>
+                  <a:srgbClr val="1F2A30"/>
+                </a:solidFill>
+              </a:rPr>
+              <a:t>Per contenuto, non per numero di riga</a:t>
+            </a:r>
+            <a:endParaRPr lang="en-US" sz="2000" dirty="0"/>
+          </a:p>
+        </p:txBody>
+      </p:sp>
+      <p:sp>
+        <p:nvSpPr>
+          <p:cNvPr id="18" name="Text 16"/>
+          <p:cNvSpPr txBox="1"/>
+          <p:nvPr/>
+        </p:nvSpPr>
+        <p:spPr>
+          <a:xfrm>
+            <a:off x="7360920" y="4892040"/>
+            <a:ext cx="4069080" cy="502920"/>
+          </a:xfrm>
+          <a:prstGeom prst="rect">
+            <a:avLst/>
+          </a:prstGeom>
+          <a:noFill/>
+          <a:ln/>
+        </p:spPr>
+        <p:txBody>
+          <a:bodyPr wrap="square" lIns="0" tIns="0" rIns="0" bIns="0" rtlCol="0" anchor="ctr"/>
+          <a:lstStyle/>
+          <a:p>
+            <a:pPr indent="0" marL="0">
+              <a:buNone/>
+            </a:pPr>
+            <a:r>
+              <a:rPr lang="en-US" sz="1600" dirty="0">
+                <a:solidFill>
+                  <a:srgbClr val="5C6F7B"/>
+                </a:solidFill>
+              </a:rPr>
+              <a:t>dopo un ordinamento la riga 500 è un'altra</a:t>
+            </a:r>
+            <a:endParaRPr lang="en-US" sz="1600" dirty="0"/>
+          </a:p>
+        </p:txBody>
+      </p:sp>
+      <p:sp>
+        <p:nvSpPr>
+          <p:cNvPr id="19" name="Text 17"/>
+          <p:cNvSpPr txBox="1"/>
+          <p:nvPr/>
+        </p:nvSpPr>
+        <p:spPr>
+          <a:xfrm>
+            <a:off x="548640" y="5760720"/>
+            <a:ext cx="11064240" cy="411480"/>
+          </a:xfrm>
+          <a:prstGeom prst="rect">
+            <a:avLst/>
+          </a:prstGeom>
+          <a:noFill/>
+          <a:ln/>
+        </p:spPr>
+        <p:txBody>
+          <a:bodyPr wrap="square" lIns="0" tIns="0" rIns="0" bIns="0" rtlCol="0" anchor="ctr"/>
+          <a:lstStyle/>
+          <a:p>
+            <a:pPr indent="0" marL="0">
+              <a:buNone/>
+            </a:pPr>
+            <a:r>
+              <a:rPr lang="en-US" sz="1700" i="1" dirty="0">
+                <a:solidFill>
+                  <a:srgbClr val="0F4C5C"/>
+                </a:solidFill>
+              </a:rPr>
+              <a:t>Due condizioni insieme: &amp;, e ognuna tra parentesi.</a:t>
+            </a:r>
+            <a:endParaRPr lang="en-US" sz="1700" dirty="0"/>
+          </a:p>
+        </p:txBody>
+      </p:sp>
+      <p:sp>
+        <p:nvSpPr>
+          <p:cNvPr id="25" name="Slide Number Placeholder 0"/>
+          <p:cNvSpPr>
+            <a:spLocks noGrp="1"/>
+          </p:cNvSpPr>
           <p:nvPr>
-            <p:ph idx="101" type="body" hasCustomPrompt="1"/>
+            <p:ph type="sldNum" sz="quarter" idx="4294967295"/>
           </p:nvPr>
         </p:nvSpPr>
         <p:spPr>
           <a:xfrm>
-            <a:off x="731520" y="3657600"/>
-            <a:ext cx="10698480" cy="1463040"/>
-          </a:xfrm>
-          <a:prstGeom prst="rect">
-            <a:avLst/>
-          </a:prstGeom>
-          <a:noFill/>
-          <a:ln/>
-        </p:spPr>
-        <p:txBody>
-          <a:bodyPr wrap="square" lIns="0" tIns="0" rIns="0" bIns="0" rtlCol="0" anchor="t"/>
-          <a:lstStyle/>
-          <a:p>
-            <a:pPr indent="0" marL="0">
-              <a:buNone/>
-            </a:pPr>
-            <a:r>
-              <a:rPr lang="en-US" sz="2200" dirty="0">
-                <a:solidFill>
-                  <a:srgbClr val="B8C4CB"/>
-                </a:solidFill>
-              </a:rPr>
-              <a:t>Obiettivo: 2.500 righe, 20 regioni, un fatturato numerico e plausibile.</a:t>
-            </a:r>
-            <a:endParaRPr lang="en-US" sz="2200" dirty="0"/>
-          </a:p>
-          <a:p>
-            <a:pPr indent="0" marL="0">
-              <a:buNone/>
-            </a:pPr>
-            <a:r>
-              <a:rPr lang="en-US" sz="2200" dirty="0">
-                <a:solidFill>
-                  <a:srgbClr val="B8C4CB"/>
-                </a:solidFill>
-              </a:rPr>
-              <a:t>60 minuti · apri il notebook dal README</a:t>
-            </a:r>
-            <a:endParaRPr lang="en-US" sz="2200" dirty="0"/>
+            <a:off x="11155680" y="6400800"/>
+            <a:ext cx="457200" cy="274320"/>
+          </a:xfrm>
+          <a:prstGeom prst="rect">
+            <a:avLst/>
+          </a:prstGeom>
+          <a:extLst>
+            <a:ext uri="{C572A759-6A51-4108-AA02-DFA0A04FC94B}">
+              <ma14:wrappingTextBoxFlag xmlns:ma14="http://schemas.microsoft.com/office/mac/drawingml/2011/main" val="0"/>
+            </a:ext>
+          </a:extLst>
+        </p:spPr>
+        <p:txBody>
+          <a:bodyPr/>
+          <a:lstStyle>
+            <a:lvl1pPr>
+              <a:defRPr sz="1000">
+                <a:solidFill>
+                  <a:srgbClr val="5C6F7B"/>
+                </a:solidFill>
+              </a:defRPr>
+            </a:lvl1pPr>
+          </a:lstStyle>
+          <a:p>
+            <a:pPr algn="r"/>
+            <a:fld id="{F7021451-1387-4CA6-816F-3879F97B5CBC}" type="slidenum">
+              <a:rPr b="0" lang="en-US"/>
+              <a:t>8</a:t>
+            </a:fld>
+            <a:endParaRPr lang="en-US"/>
           </a:p>
         </p:txBody>
       </p:sp>
@@ -8347,7 +9123,7 @@
                   <a:srgbClr val="FFFFFF"/>
                 </a:solidFill>
               </a:rPr>
-              <a:t>Debrief</a:t>
+              <a:t>Task: pulisci il dataset</a:t>
             </a:r>
             <a:endParaRPr lang="en-US" sz="5400" dirty="0"/>
           </a:p>
@@ -8385,7 +9161,21 @@
                   <a:srgbClr val="B8C4CB"/>
                 </a:solidFill>
               </a:rPr>
-              <a:t>Le trappole silenziose</a:t>
+              <a:t>Obiettivo: 2.500 righe, 20 regioni, un fatturato numerico e plausibile.</a:t>
+            </a:r>
+            <a:endParaRPr lang="en-US" sz="2200" dirty="0"/>
+          </a:p>
+          <a:p>
+            <a:pPr indent="0" marL="0">
+              <a:buNone/>
+            </a:pPr>
+            <a:r>
+              <a:rPr lang="en-US" sz="2200" dirty="0">
+                <a:solidFill>
+                  <a:srgbClr val="B8C4CB"/>
+                </a:solidFill>
+              </a:rPr>
+              <a:t>60 minuti · apri il notebook dal README</a:t>
             </a:r>
             <a:endParaRPr lang="en-US" sz="2200" dirty="0"/>
           </a:p>

</xml_diff>